<commit_message>
changes in r1 ppt
</commit_message>
<xml_diff>
--- a/Review1_agentic.pptx
+++ b/Review1_agentic.pptx
@@ -9,12 +9,13 @@
     <p:sldId id="2147470492" r:id="rId3"/>
     <p:sldId id="2147470493" r:id="rId4"/>
     <p:sldId id="2147470494" r:id="rId5"/>
-    <p:sldId id="2147470495" r:id="rId6"/>
-    <p:sldId id="2147470496" r:id="rId7"/>
-    <p:sldId id="2147470497" r:id="rId8"/>
-    <p:sldId id="2147470498" r:id="rId9"/>
-    <p:sldId id="2147470499" r:id="rId10"/>
-    <p:sldId id="2147470491" r:id="rId11"/>
+    <p:sldId id="2147470496" r:id="rId6"/>
+    <p:sldId id="2147470497" r:id="rId7"/>
+    <p:sldId id="2147470498" r:id="rId8"/>
+    <p:sldId id="2147470499" r:id="rId9"/>
+    <p:sldId id="2147470491" r:id="rId10"/>
+    <p:sldId id="2147470500" r:id="rId11"/>
+    <p:sldId id="2147470495" r:id="rId12"/>
   </p:sldIdLst>
   <p:sldSz cx="12192000" cy="6858000"/>
   <p:notesSz cx="6858000" cy="9144000"/>
@@ -4128,475 +4129,10 @@
       </p:grpSpPr>
       <p:sp>
         <p:nvSpPr>
-          <p:cNvPr id="3" name="TextBox 2">
-            <a:extLst>
-              <a:ext uri="{FF2B5EF4-FFF2-40B4-BE49-F238E27FC236}">
-                <a16:creationId xmlns:a16="http://schemas.microsoft.com/office/drawing/2014/main" id="{25EA9B7F-B60D-6297-DC95-0FDA7E6D7C7C}"/>
-              </a:ext>
-            </a:extLst>
-          </p:cNvPr>
-          <p:cNvSpPr txBox="1"/>
-          <p:nvPr/>
-        </p:nvSpPr>
-        <p:spPr>
-          <a:xfrm>
-            <a:off x="255996" y="502545"/>
-            <a:ext cx="10624338" cy="646331"/>
-          </a:xfrm>
-          <a:prstGeom prst="rect">
-            <a:avLst/>
-          </a:prstGeom>
-          <a:noFill/>
-        </p:spPr>
-        <p:txBody>
-          <a:bodyPr wrap="square" rtlCol="0">
-            <a:spAutoFit/>
-          </a:bodyPr>
-          <a:lstStyle/>
-          <a:p>
-            <a:pPr marL="0" marR="0" lvl="0" indent="0" algn="l" defTabSz="914400" rtl="0" eaLnBrk="1" fontAlgn="auto" latinLnBrk="0" hangingPunct="1">
-              <a:lnSpc>
-                <a:spcPct val="100000"/>
-              </a:lnSpc>
-              <a:spcBef>
-                <a:spcPts val="0"/>
-              </a:spcBef>
-              <a:spcAft>
-                <a:spcPts val="0"/>
-              </a:spcAft>
-              <a:buClrTx/>
-              <a:buSzTx/>
-              <a:buFontTx/>
-              <a:buNone/>
-              <a:tabLst/>
-              <a:defRPr/>
-            </a:pPr>
-            <a:r>
-              <a:rPr kumimoji="0" lang="en-US" sz="3600" b="1" i="0" u="none" strike="noStrike" kern="1200" cap="none" spc="0" normalizeH="0" baseline="0" noProof="0" dirty="0">
-                <a:ln>
-                  <a:noFill/>
-                </a:ln>
-                <a:solidFill>
-                  <a:srgbClr val="5B9BD5">
-                    <a:lumMod val="50000"/>
-                  </a:srgbClr>
-                </a:solidFill>
-                <a:effectLst/>
-                <a:uLnTx/>
-                <a:uFillTx/>
-                <a:latin typeface="Calibri" panose="020F0502020204030204"/>
-                <a:ea typeface="+mn-ea"/>
-                <a:cs typeface="+mn-cs"/>
-              </a:rPr>
-              <a:t>Modules to cover</a:t>
-            </a:r>
-          </a:p>
-        </p:txBody>
-      </p:sp>
-      <p:cxnSp>
-        <p:nvCxnSpPr>
-          <p:cNvPr id="5" name="Straight Connector 4">
-            <a:extLst>
-              <a:ext uri="{FF2B5EF4-FFF2-40B4-BE49-F238E27FC236}">
-                <a16:creationId xmlns:a16="http://schemas.microsoft.com/office/drawing/2014/main" id="{25CD5B67-3503-60B5-8469-F3C3191D84D7}"/>
-              </a:ext>
-            </a:extLst>
-          </p:cNvPr>
-          <p:cNvCxnSpPr>
-            <a:cxnSpLocks/>
-          </p:cNvCxnSpPr>
-          <p:nvPr/>
-        </p:nvCxnSpPr>
-        <p:spPr>
-          <a:xfrm>
-            <a:off x="221274" y="1191756"/>
-            <a:ext cx="7305799" cy="0"/>
-          </a:xfrm>
-          <a:prstGeom prst="line">
-            <a:avLst/>
-          </a:prstGeom>
-          <a:ln w="28575">
-            <a:solidFill>
-              <a:schemeClr val="accent6"/>
-            </a:solidFill>
-          </a:ln>
-        </p:spPr>
-        <p:style>
-          <a:lnRef idx="1">
-            <a:schemeClr val="accent1"/>
-          </a:lnRef>
-          <a:fillRef idx="0">
-            <a:schemeClr val="accent1"/>
-          </a:fillRef>
-          <a:effectRef idx="0">
-            <a:schemeClr val="accent1"/>
-          </a:effectRef>
-          <a:fontRef idx="minor">
-            <a:schemeClr val="tx1"/>
-          </a:fontRef>
-        </p:style>
-      </p:cxnSp>
-      <p:sp>
-        <p:nvSpPr>
-          <p:cNvPr id="4" name="TextBox 3">
-            <a:extLst>
-              <a:ext uri="{FF2B5EF4-FFF2-40B4-BE49-F238E27FC236}">
-                <a16:creationId xmlns:a16="http://schemas.microsoft.com/office/drawing/2014/main" id="{5D4A0452-2CB8-E4C6-FAC7-ECD109C50CE1}"/>
-              </a:ext>
-            </a:extLst>
-          </p:cNvPr>
-          <p:cNvSpPr txBox="1"/>
-          <p:nvPr/>
-        </p:nvSpPr>
-        <p:spPr>
-          <a:xfrm>
-            <a:off x="4898571" y="57036"/>
-            <a:ext cx="7293429" cy="369332"/>
-          </a:xfrm>
-          <a:prstGeom prst="rect">
-            <a:avLst/>
-          </a:prstGeom>
-          <a:noFill/>
-        </p:spPr>
-        <p:txBody>
-          <a:bodyPr wrap="square" rtlCol="0">
-            <a:spAutoFit/>
-          </a:bodyPr>
-          <a:lstStyle/>
-          <a:p>
-            <a:pPr lvl="0" algn="ctr">
-              <a:defRPr/>
-            </a:pPr>
-            <a:r>
-              <a:rPr lang="en-GB" b="1" dirty="0">
-                <a:solidFill>
-                  <a:prstClr val="white"/>
-                </a:solidFill>
-                <a:cs typeface="Calibri" panose="020F0502020204030204" pitchFamily="34" charset="0"/>
-              </a:rPr>
-              <a:t>Deterministic MCP-Driven AI Agents for Ball Bearing Vibration Diagnostics</a:t>
-            </a:r>
-            <a:endParaRPr lang="en-US" b="1" dirty="0">
-              <a:solidFill>
-                <a:prstClr val="white"/>
-              </a:solidFill>
-              <a:cs typeface="Calibri" panose="020F0502020204030204" pitchFamily="34" charset="0"/>
-            </a:endParaRPr>
-          </a:p>
-        </p:txBody>
-      </p:sp>
-      <p:sp>
-        <p:nvSpPr>
-          <p:cNvPr id="6" name="TextBox 5">
-            <a:extLst>
-              <a:ext uri="{FF2B5EF4-FFF2-40B4-BE49-F238E27FC236}">
-                <a16:creationId xmlns:a16="http://schemas.microsoft.com/office/drawing/2014/main" id="{8F69BBE3-6CB4-2639-F479-D4BD440A32A4}"/>
-              </a:ext>
-            </a:extLst>
-          </p:cNvPr>
-          <p:cNvSpPr txBox="1"/>
-          <p:nvPr/>
-        </p:nvSpPr>
-        <p:spPr>
-          <a:xfrm>
-            <a:off x="6725264" y="1357505"/>
-            <a:ext cx="6098107" cy="3970318"/>
-          </a:xfrm>
-          <a:prstGeom prst="rect">
-            <a:avLst/>
-          </a:prstGeom>
-          <a:noFill/>
-        </p:spPr>
-        <p:txBody>
-          <a:bodyPr wrap="square" rtlCol="0">
-            <a:spAutoFit/>
-          </a:bodyPr>
-          <a:lstStyle/>
-          <a:p>
-            <a:pPr>
-              <a:buNone/>
-            </a:pPr>
-            <a:r>
-              <a:rPr lang="en-IN" b="1" dirty="0">
-                <a:solidFill>
-                  <a:schemeClr val="accent1"/>
-                </a:solidFill>
-              </a:rPr>
-              <a:t>4. Deterministic Diagnostic Engine</a:t>
-            </a:r>
-            <a:endParaRPr lang="en-IN" dirty="0">
-              <a:solidFill>
-                <a:schemeClr val="accent1"/>
-              </a:solidFill>
-            </a:endParaRPr>
-          </a:p>
-          <a:p>
-            <a:pPr marL="342900" lvl="0" indent="-342900">
-              <a:buFont typeface="Arial" panose="020B0604020202020204" pitchFamily="34" charset="0"/>
-              <a:buChar char="•"/>
-            </a:pPr>
-            <a:r>
-              <a:rPr lang="en-IN" dirty="0">
-                <a:solidFill>
-                  <a:schemeClr val="accent1"/>
-                </a:solidFill>
-              </a:rPr>
-              <a:t>Rule/threshold-based decision logic </a:t>
-            </a:r>
-          </a:p>
-          <a:p>
-            <a:pPr marL="342900" lvl="0" indent="-342900">
-              <a:buFont typeface="Arial" panose="020B0604020202020204" pitchFamily="34" charset="0"/>
-              <a:buChar char="•"/>
-            </a:pPr>
-            <a:r>
-              <a:rPr lang="en-IN" dirty="0">
-                <a:solidFill>
-                  <a:schemeClr val="accent1"/>
-                </a:solidFill>
-              </a:rPr>
-              <a:t>Consistent and reproducible diagnosis </a:t>
-            </a:r>
-          </a:p>
-          <a:p>
-            <a:pPr marL="342900" lvl="0" indent="-342900">
-              <a:buFont typeface="Arial" panose="020B0604020202020204" pitchFamily="34" charset="0"/>
-              <a:buChar char="•"/>
-            </a:pPr>
-            <a:r>
-              <a:rPr lang="en-IN" dirty="0">
-                <a:solidFill>
-                  <a:schemeClr val="accent1"/>
-                </a:solidFill>
-              </a:rPr>
-              <a:t>ISO-based diagnostic criteria </a:t>
-            </a:r>
-          </a:p>
-          <a:p>
-            <a:pPr lvl="0"/>
-            <a:endParaRPr lang="en-IN" dirty="0">
-              <a:solidFill>
-                <a:schemeClr val="accent1"/>
-              </a:solidFill>
-            </a:endParaRPr>
-          </a:p>
-          <a:p>
-            <a:pPr>
-              <a:buNone/>
-            </a:pPr>
-            <a:r>
-              <a:rPr lang="en-IN" b="1" dirty="0">
-                <a:solidFill>
-                  <a:schemeClr val="accent1"/>
-                </a:solidFill>
-              </a:rPr>
-              <a:t>5. MCP-Driven AI Agent</a:t>
-            </a:r>
-            <a:endParaRPr lang="en-IN" dirty="0">
-              <a:solidFill>
-                <a:schemeClr val="accent1"/>
-              </a:solidFill>
-            </a:endParaRPr>
-          </a:p>
-          <a:p>
-            <a:pPr marL="342900" lvl="0" indent="-342900">
-              <a:buFont typeface="Arial" panose="020B0604020202020204" pitchFamily="34" charset="0"/>
-              <a:buChar char="•"/>
-            </a:pPr>
-            <a:r>
-              <a:rPr lang="en-IN" dirty="0">
-                <a:solidFill>
-                  <a:schemeClr val="accent1"/>
-                </a:solidFill>
-              </a:rPr>
-              <a:t>MCP tools and structured context </a:t>
-            </a:r>
-          </a:p>
-          <a:p>
-            <a:pPr marL="342900" lvl="0" indent="-342900">
-              <a:buFont typeface="Arial" panose="020B0604020202020204" pitchFamily="34" charset="0"/>
-              <a:buChar char="•"/>
-            </a:pPr>
-            <a:r>
-              <a:rPr lang="en-IN" dirty="0">
-                <a:solidFill>
-                  <a:schemeClr val="accent1"/>
-                </a:solidFill>
-              </a:rPr>
-              <a:t>Agent-based diagnostic workflow </a:t>
-            </a:r>
-          </a:p>
-          <a:p>
-            <a:pPr marL="342900" lvl="0" indent="-342900">
-              <a:buFont typeface="Arial" panose="020B0604020202020204" pitchFamily="34" charset="0"/>
-              <a:buChar char="•"/>
-            </a:pPr>
-            <a:r>
-              <a:rPr lang="en-IN" dirty="0">
-                <a:solidFill>
-                  <a:schemeClr val="accent1"/>
-                </a:solidFill>
-              </a:rPr>
-              <a:t>Explainable reasoning and fault identification</a:t>
-            </a:r>
-          </a:p>
-          <a:p>
-            <a:pPr lvl="0"/>
-            <a:r>
-              <a:rPr lang="en-IN" dirty="0">
-                <a:solidFill>
-                  <a:schemeClr val="accent1"/>
-                </a:solidFill>
-              </a:rPr>
-              <a:t> </a:t>
-            </a:r>
-          </a:p>
-          <a:p>
-            <a:pPr>
-              <a:buNone/>
-            </a:pPr>
-            <a:r>
-              <a:rPr lang="en-IN" b="1" dirty="0">
-                <a:solidFill>
-                  <a:schemeClr val="accent1"/>
-                </a:solidFill>
-              </a:rPr>
-              <a:t>6. Results &amp; Validation</a:t>
-            </a:r>
-            <a:endParaRPr lang="en-IN" dirty="0">
-              <a:solidFill>
-                <a:schemeClr val="accent1"/>
-              </a:solidFill>
-            </a:endParaRPr>
-          </a:p>
-          <a:p>
-            <a:pPr marL="342900" lvl="0" indent="-342900">
-              <a:buFont typeface="Arial" panose="020B0604020202020204" pitchFamily="34" charset="0"/>
-              <a:buChar char="•"/>
-            </a:pPr>
-            <a:r>
-              <a:rPr lang="en-IN" dirty="0">
-                <a:solidFill>
-                  <a:schemeClr val="accent1"/>
-                </a:solidFill>
-              </a:rPr>
-              <a:t>Bearing fault classification </a:t>
-            </a:r>
-          </a:p>
-          <a:p>
-            <a:pPr marL="342900" lvl="0" indent="-342900">
-              <a:buFont typeface="Arial" panose="020B0604020202020204" pitchFamily="34" charset="0"/>
-              <a:buChar char="•"/>
-            </a:pPr>
-            <a:r>
-              <a:rPr lang="en-IN" dirty="0">
-                <a:solidFill>
-                  <a:schemeClr val="accent1"/>
-                </a:solidFill>
-              </a:rPr>
-              <a:t>Diagnostic explanation </a:t>
-            </a:r>
-          </a:p>
-          <a:p>
-            <a:pPr marL="342900" lvl="0" indent="-342900">
-              <a:buFont typeface="Arial" panose="020B0604020202020204" pitchFamily="34" charset="0"/>
-              <a:buChar char="•"/>
-            </a:pPr>
-            <a:r>
-              <a:rPr lang="en-IN" dirty="0">
-                <a:solidFill>
-                  <a:schemeClr val="accent1"/>
-                </a:solidFill>
-              </a:rPr>
-              <a:t>Accuracy and consistency evaluation</a:t>
-            </a:r>
-          </a:p>
-        </p:txBody>
-      </p:sp>
-      <p:pic>
-        <p:nvPicPr>
-          <p:cNvPr id="14" name="Picture 13">
-            <a:extLst>
-              <a:ext uri="{FF2B5EF4-FFF2-40B4-BE49-F238E27FC236}">
-                <a16:creationId xmlns:a16="http://schemas.microsoft.com/office/drawing/2014/main" id="{706454FF-9B5F-5325-55EB-6DC7C5C5E991}"/>
-              </a:ext>
-            </a:extLst>
-          </p:cNvPr>
-          <p:cNvPicPr>
-            <a:picLocks noChangeAspect="1"/>
-          </p:cNvPicPr>
-          <p:nvPr/>
-        </p:nvPicPr>
-        <p:blipFill>
-          <a:blip r:embed="rId2"/>
-          <a:stretch>
-            <a:fillRect/>
-          </a:stretch>
-        </p:blipFill>
-        <p:spPr>
-          <a:xfrm>
-            <a:off x="1248389" y="1357505"/>
-            <a:ext cx="5476875" cy="4972050"/>
-          </a:xfrm>
-          <a:prstGeom prst="rect">
-            <a:avLst/>
-          </a:prstGeom>
-        </p:spPr>
-      </p:pic>
-    </p:spTree>
-    <p:extLst>
-      <p:ext uri="{BB962C8B-B14F-4D97-AF65-F5344CB8AC3E}">
-        <p14:creationId xmlns:p14="http://schemas.microsoft.com/office/powerpoint/2010/main" val="1187364388"/>
-      </p:ext>
-    </p:extLst>
-  </p:cSld>
-  <p:clrMapOvr>
-    <a:masterClrMapping/>
-  </p:clrMapOvr>
-  <mc:AlternateContent xmlns:mc="http://schemas.openxmlformats.org/markup-compatibility/2006" xmlns:p14="http://schemas.microsoft.com/office/powerpoint/2010/main">
-    <mc:Choice Requires="p14">
-      <p:transition spd="med" p14:dur="700">
-        <p:fade/>
-      </p:transition>
-    </mc:Choice>
-    <mc:Fallback xmlns="">
-      <p:transition spd="med">
-        <p:fade/>
-      </p:transition>
-    </mc:Fallback>
-  </mc:AlternateContent>
-</p:sld>
-</file>
-
-<file path=ppt/slides/slide2.xml><?xml version="1.0" encoding="utf-8"?>
-<p:sld xmlns:a="http://schemas.openxmlformats.org/drawingml/2006/main" xmlns:r="http://schemas.openxmlformats.org/officeDocument/2006/relationships" xmlns:p="http://schemas.openxmlformats.org/presentationml/2006/main">
-  <p:cSld>
-    <p:spTree>
-      <p:nvGrpSpPr>
-        <p:cNvPr id="1" name="">
-          <a:extLst>
-            <a:ext uri="{FF2B5EF4-FFF2-40B4-BE49-F238E27FC236}">
-              <a16:creationId xmlns:a16="http://schemas.microsoft.com/office/drawing/2014/main" id="{13318EFD-13D1-118F-A8E4-F9E2D3695A6C}"/>
-            </a:ext>
-          </a:extLst>
-        </p:cNvPr>
-        <p:cNvGrpSpPr/>
-        <p:nvPr/>
-      </p:nvGrpSpPr>
-      <p:grpSpPr>
-        <a:xfrm>
-          <a:off x="0" y="0"/>
-          <a:ext cx="0" cy="0"/>
-          <a:chOff x="0" y="0"/>
-          <a:chExt cx="0" cy="0"/>
-        </a:xfrm>
-      </p:grpSpPr>
-      <p:sp>
-        <p:nvSpPr>
           <p:cNvPr id="2" name="Text Placeholder 1">
             <a:extLst>
               <a:ext uri="{FF2B5EF4-FFF2-40B4-BE49-F238E27FC236}">
-                <a16:creationId xmlns:a16="http://schemas.microsoft.com/office/drawing/2014/main" id="{67726612-73E0-5A94-F635-3A742DD5BA94}"/>
+                <a16:creationId xmlns:a16="http://schemas.microsoft.com/office/drawing/2014/main" id="{F59BCA32-5BCA-2276-E999-19E06D5EC85C}"/>
               </a:ext>
             </a:extLst>
           </p:cNvPr>
@@ -4607,1891 +4143,54 @@
             <p:ph type="body" sz="quarter" idx="13"/>
           </p:nvPr>
         </p:nvSpPr>
-        <p:spPr>
-          <a:xfrm>
-            <a:off x="255996" y="1271219"/>
-            <a:ext cx="10624338" cy="4142989"/>
-          </a:xfrm>
-        </p:spPr>
+        <p:spPr/>
         <p:txBody>
           <a:bodyPr/>
           <a:lstStyle/>
           <a:p>
-            <a:pPr marL="342900" lvl="0" indent="-342900"/>
-            <a:r>
-              <a:rPr lang="en-IN" sz="2400" dirty="0">
-                <a:latin typeface="+mn-lt"/>
-              </a:rPr>
-              <a:t>Industrial rotating machinery is highly dependent on the reliable operation of rolling-element bearings. </a:t>
-            </a:r>
-          </a:p>
-          <a:p>
-            <a:pPr marL="342900" lvl="0" indent="-342900"/>
-            <a:r>
-              <a:rPr lang="en-IN" sz="2400" dirty="0">
-                <a:latin typeface="+mn-lt"/>
-              </a:rPr>
-              <a:t>Bearing faults can cause unexpected machine downtime, reduced efficiency, increased maintenance costs, and potential equipment failure. </a:t>
-            </a:r>
-          </a:p>
-          <a:p>
-            <a:pPr marL="342900" lvl="0" indent="-342900"/>
-            <a:r>
-              <a:rPr lang="en-IN" sz="2400" dirty="0">
-                <a:latin typeface="+mn-lt"/>
-              </a:rPr>
-              <a:t>Vibration analysis is a widely used technique for detecting and identifying bearing health conditions. </a:t>
-            </a:r>
-          </a:p>
-          <a:p>
-            <a:pPr marL="342900" lvl="0" indent="-342900"/>
-            <a:r>
-              <a:rPr lang="en-IN" sz="2400" dirty="0">
-                <a:latin typeface="+mn-lt"/>
-              </a:rPr>
-              <a:t>Traditional AI-based diagnostic systems may produce probabilistic predictions, making their reasoning difficult to validate and reproduce consistently. </a:t>
-            </a:r>
-          </a:p>
-          <a:p>
-            <a:pPr marL="342900" lvl="0" indent="-342900"/>
-            <a:r>
-              <a:rPr lang="en-IN" sz="2400" dirty="0">
-                <a:latin typeface="+mn-lt"/>
-              </a:rPr>
-              <a:t>This project proposes a Deterministic MCP (Model Context Protocol)-Driven AI Agent for reliable and explainable ball bearing fault diagnosis. </a:t>
-            </a:r>
-          </a:p>
-          <a:p>
-            <a:pPr marL="342900" lvl="0" indent="-342900"/>
-            <a:r>
-              <a:rPr lang="en-IN" sz="2400" dirty="0">
-                <a:latin typeface="+mn-lt"/>
-              </a:rPr>
-              <a:t>The system uses the NASA Bearing Dataset as the primary source of vibration data for developing and evaluating the diagnostic approach.</a:t>
-            </a:r>
-          </a:p>
-          <a:p>
-            <a:pPr marL="0" indent="0">
-              <a:lnSpc>
-                <a:spcPct val="150000"/>
-              </a:lnSpc>
-              <a:buNone/>
-            </a:pPr>
-            <a:endParaRPr lang="en-US" sz="2400" b="0" dirty="0">
-              <a:solidFill>
-                <a:srgbClr val="5583D1"/>
-              </a:solidFill>
-              <a:latin typeface="+mn-lt"/>
-            </a:endParaRPr>
+            <a:endParaRPr lang="en-IN"/>
           </a:p>
         </p:txBody>
       </p:sp>
       <p:sp>
         <p:nvSpPr>
-          <p:cNvPr id="3" name="TextBox 2">
+          <p:cNvPr id="3" name="Text Placeholder 2">
             <a:extLst>
               <a:ext uri="{FF2B5EF4-FFF2-40B4-BE49-F238E27FC236}">
-                <a16:creationId xmlns:a16="http://schemas.microsoft.com/office/drawing/2014/main" id="{AB4E3812-AF2F-9DD8-6ECF-C3425146B38F}"/>
+                <a16:creationId xmlns:a16="http://schemas.microsoft.com/office/drawing/2014/main" id="{296C34B2-95EA-45E4-1038-CD98F14C037B}"/>
               </a:ext>
             </a:extLst>
           </p:cNvPr>
-          <p:cNvSpPr txBox="1"/>
-          <p:nvPr/>
+          <p:cNvSpPr>
+            <a:spLocks noGrp="1"/>
+          </p:cNvSpPr>
+          <p:nvPr>
+            <p:ph type="body" sz="quarter" idx="15"/>
+          </p:nvPr>
         </p:nvSpPr>
-        <p:spPr>
-          <a:xfrm>
-            <a:off x="255996" y="502545"/>
-            <a:ext cx="10624338" cy="646331"/>
-          </a:xfrm>
-          <a:prstGeom prst="rect">
-            <a:avLst/>
-          </a:prstGeom>
-          <a:noFill/>
-        </p:spPr>
+        <p:spPr/>
         <p:txBody>
-          <a:bodyPr wrap="square" rtlCol="0">
-            <a:spAutoFit/>
-          </a:bodyPr>
+          <a:bodyPr/>
           <a:lstStyle/>
           <a:p>
-            <a:pPr marL="0" marR="0" lvl="0" indent="0" algn="l" defTabSz="914400" rtl="0" eaLnBrk="1" fontAlgn="auto" latinLnBrk="0" hangingPunct="1">
-              <a:lnSpc>
-                <a:spcPct val="100000"/>
-              </a:lnSpc>
-              <a:spcBef>
-                <a:spcPts val="0"/>
-              </a:spcBef>
-              <a:spcAft>
-                <a:spcPts val="0"/>
-              </a:spcAft>
-              <a:buClrTx/>
-              <a:buSzTx/>
-              <a:buFontTx/>
-              <a:buNone/>
-              <a:tabLst/>
-              <a:defRPr/>
-            </a:pPr>
-            <a:r>
-              <a:rPr kumimoji="0" lang="en-US" sz="3600" b="1" i="0" u="none" strike="noStrike" kern="1200" cap="none" spc="0" normalizeH="0" baseline="0" noProof="0" dirty="0">
-                <a:ln>
-                  <a:noFill/>
-                </a:ln>
-                <a:solidFill>
-                  <a:srgbClr val="5B9BD5">
-                    <a:lumMod val="50000"/>
-                  </a:srgbClr>
-                </a:solidFill>
-                <a:effectLst/>
-                <a:uLnTx/>
-                <a:uFillTx/>
-                <a:latin typeface="Calibri" panose="020F0502020204030204"/>
-                <a:ea typeface="+mn-ea"/>
-                <a:cs typeface="+mn-cs"/>
-              </a:rPr>
-              <a:t>Introduction</a:t>
-            </a:r>
-          </a:p>
-        </p:txBody>
-      </p:sp>
-      <p:cxnSp>
-        <p:nvCxnSpPr>
-          <p:cNvPr id="5" name="Straight Connector 4">
-            <a:extLst>
-              <a:ext uri="{FF2B5EF4-FFF2-40B4-BE49-F238E27FC236}">
-                <a16:creationId xmlns:a16="http://schemas.microsoft.com/office/drawing/2014/main" id="{A295426A-3395-FE92-30C7-C8A6AC62DE62}"/>
-              </a:ext>
-            </a:extLst>
-          </p:cNvPr>
-          <p:cNvCxnSpPr>
-            <a:cxnSpLocks/>
-          </p:cNvCxnSpPr>
-          <p:nvPr/>
-        </p:nvCxnSpPr>
-        <p:spPr>
-          <a:xfrm>
-            <a:off x="221274" y="1191756"/>
-            <a:ext cx="7305799" cy="0"/>
-          </a:xfrm>
-          <a:prstGeom prst="line">
-            <a:avLst/>
-          </a:prstGeom>
-          <a:ln w="28575">
-            <a:solidFill>
-              <a:schemeClr val="accent6"/>
-            </a:solidFill>
-          </a:ln>
-        </p:spPr>
-        <p:style>
-          <a:lnRef idx="1">
-            <a:schemeClr val="accent1"/>
-          </a:lnRef>
-          <a:fillRef idx="0">
-            <a:schemeClr val="accent1"/>
-          </a:fillRef>
-          <a:effectRef idx="0">
-            <a:schemeClr val="accent1"/>
-          </a:effectRef>
-          <a:fontRef idx="minor">
-            <a:schemeClr val="tx1"/>
-          </a:fontRef>
-        </p:style>
-      </p:cxnSp>
-      <p:sp>
-        <p:nvSpPr>
-          <p:cNvPr id="4" name="TextBox 3">
-            <a:extLst>
-              <a:ext uri="{FF2B5EF4-FFF2-40B4-BE49-F238E27FC236}">
-                <a16:creationId xmlns:a16="http://schemas.microsoft.com/office/drawing/2014/main" id="{2D91B1D4-191E-E882-BD37-9FBAED57B57F}"/>
-              </a:ext>
-            </a:extLst>
-          </p:cNvPr>
-          <p:cNvSpPr txBox="1"/>
-          <p:nvPr/>
-        </p:nvSpPr>
-        <p:spPr>
-          <a:xfrm>
-            <a:off x="4735287" y="57036"/>
-            <a:ext cx="7456714" cy="369332"/>
-          </a:xfrm>
-          <a:prstGeom prst="rect">
-            <a:avLst/>
-          </a:prstGeom>
-          <a:noFill/>
-        </p:spPr>
-        <p:txBody>
-          <a:bodyPr wrap="square" rtlCol="0">
-            <a:spAutoFit/>
-          </a:bodyPr>
-          <a:lstStyle/>
-          <a:p>
-            <a:pPr lvl="0" algn="ctr">
-              <a:defRPr/>
-            </a:pPr>
-            <a:r>
-              <a:rPr lang="en-GB" b="1" dirty="0">
-                <a:solidFill>
-                  <a:prstClr val="white"/>
-                </a:solidFill>
-                <a:cs typeface="Calibri" panose="020F0502020204030204" pitchFamily="34" charset="0"/>
-              </a:rPr>
-              <a:t>Deterministic MCP-Driven AI Agents for Ball Bearing Vibration Diagnostics</a:t>
-            </a:r>
-            <a:endParaRPr lang="en-US" b="1" dirty="0">
-              <a:solidFill>
-                <a:prstClr val="white"/>
-              </a:solidFill>
-              <a:cs typeface="Calibri" panose="020F0502020204030204" pitchFamily="34" charset="0"/>
-            </a:endParaRPr>
+            <a:endParaRPr lang="en-IN"/>
           </a:p>
         </p:txBody>
       </p:sp>
     </p:spTree>
     <p:extLst>
       <p:ext uri="{BB962C8B-B14F-4D97-AF65-F5344CB8AC3E}">
-        <p14:creationId xmlns:p14="http://schemas.microsoft.com/office/powerpoint/2010/main" val="2088180620"/>
+        <p14:creationId xmlns:p14="http://schemas.microsoft.com/office/powerpoint/2010/main" val="1664113889"/>
       </p:ext>
     </p:extLst>
   </p:cSld>
   <p:clrMapOvr>
     <a:masterClrMapping/>
   </p:clrMapOvr>
-  <mc:AlternateContent xmlns:mc="http://schemas.openxmlformats.org/markup-compatibility/2006" xmlns:p14="http://schemas.microsoft.com/office/powerpoint/2010/main">
-    <mc:Choice Requires="p14">
-      <p:transition spd="med" p14:dur="700">
-        <p:fade/>
-      </p:transition>
-    </mc:Choice>
-    <mc:Fallback xmlns="">
-      <p:transition spd="med">
-        <p:fade/>
-      </p:transition>
-    </mc:Fallback>
-  </mc:AlternateContent>
-  <p:timing>
-    <p:tnLst>
-      <p:par>
-        <p:cTn id="1" dur="indefinite" restart="never" nodeType="tmRoot">
-          <p:childTnLst>
-            <p:seq concurrent="1" nextAc="seek">
-              <p:cTn id="2" dur="indefinite" nodeType="mainSeq">
-                <p:childTnLst>
-                  <p:par>
-                    <p:cTn id="3" fill="hold">
-                      <p:stCondLst>
-                        <p:cond delay="indefinite"/>
-                      </p:stCondLst>
-                      <p:childTnLst>
-                        <p:par>
-                          <p:cTn id="4" fill="hold">
-                            <p:stCondLst>
-                              <p:cond delay="0"/>
-                            </p:stCondLst>
-                            <p:childTnLst>
-                              <p:par>
-                                <p:cTn id="5" presetID="1" presetClass="entr" presetSubtype="0" fill="hold" grpId="0" nodeType="clickEffect">
-                                  <p:stCondLst>
-                                    <p:cond delay="0"/>
-                                  </p:stCondLst>
-                                  <p:childTnLst>
-                                    <p:set>
-                                      <p:cBhvr>
-                                        <p:cTn id="6" dur="1" fill="hold">
-                                          <p:stCondLst>
-                                            <p:cond delay="0"/>
-                                          </p:stCondLst>
-                                        </p:cTn>
-                                        <p:tgtEl>
-                                          <p:spTgt spid="2">
-                                            <p:txEl>
-                                              <p:pRg st="0" end="0"/>
-                                            </p:txEl>
-                                          </p:spTgt>
-                                        </p:tgtEl>
-                                        <p:attrNameLst>
-                                          <p:attrName>style.visibility</p:attrName>
-                                        </p:attrNameLst>
-                                      </p:cBhvr>
-                                      <p:to>
-                                        <p:strVal val="visible"/>
-                                      </p:to>
-                                    </p:set>
-                                  </p:childTnLst>
-                                </p:cTn>
-                              </p:par>
-                            </p:childTnLst>
-                          </p:cTn>
-                        </p:par>
-                      </p:childTnLst>
-                    </p:cTn>
-                  </p:par>
-                  <p:par>
-                    <p:cTn id="7" fill="hold">
-                      <p:stCondLst>
-                        <p:cond delay="indefinite"/>
-                      </p:stCondLst>
-                      <p:childTnLst>
-                        <p:par>
-                          <p:cTn id="8" fill="hold">
-                            <p:stCondLst>
-                              <p:cond delay="0"/>
-                            </p:stCondLst>
-                            <p:childTnLst>
-                              <p:par>
-                                <p:cTn id="9" presetID="1" presetClass="entr" presetSubtype="0" fill="hold" grpId="0" nodeType="clickEffect">
-                                  <p:stCondLst>
-                                    <p:cond delay="0"/>
-                                  </p:stCondLst>
-                                  <p:childTnLst>
-                                    <p:set>
-                                      <p:cBhvr>
-                                        <p:cTn id="10" dur="1" fill="hold">
-                                          <p:stCondLst>
-                                            <p:cond delay="0"/>
-                                          </p:stCondLst>
-                                        </p:cTn>
-                                        <p:tgtEl>
-                                          <p:spTgt spid="2">
-                                            <p:txEl>
-                                              <p:pRg st="1" end="1"/>
-                                            </p:txEl>
-                                          </p:spTgt>
-                                        </p:tgtEl>
-                                        <p:attrNameLst>
-                                          <p:attrName>style.visibility</p:attrName>
-                                        </p:attrNameLst>
-                                      </p:cBhvr>
-                                      <p:to>
-                                        <p:strVal val="visible"/>
-                                      </p:to>
-                                    </p:set>
-                                  </p:childTnLst>
-                                </p:cTn>
-                              </p:par>
-                            </p:childTnLst>
-                          </p:cTn>
-                        </p:par>
-                      </p:childTnLst>
-                    </p:cTn>
-                  </p:par>
-                  <p:par>
-                    <p:cTn id="11" fill="hold">
-                      <p:stCondLst>
-                        <p:cond delay="indefinite"/>
-                      </p:stCondLst>
-                      <p:childTnLst>
-                        <p:par>
-                          <p:cTn id="12" fill="hold">
-                            <p:stCondLst>
-                              <p:cond delay="0"/>
-                            </p:stCondLst>
-                            <p:childTnLst>
-                              <p:par>
-                                <p:cTn id="13" presetID="1" presetClass="entr" presetSubtype="0" fill="hold" grpId="0" nodeType="clickEffect">
-                                  <p:stCondLst>
-                                    <p:cond delay="0"/>
-                                  </p:stCondLst>
-                                  <p:childTnLst>
-                                    <p:set>
-                                      <p:cBhvr>
-                                        <p:cTn id="14" dur="1" fill="hold">
-                                          <p:stCondLst>
-                                            <p:cond delay="0"/>
-                                          </p:stCondLst>
-                                        </p:cTn>
-                                        <p:tgtEl>
-                                          <p:spTgt spid="2">
-                                            <p:txEl>
-                                              <p:pRg st="2" end="2"/>
-                                            </p:txEl>
-                                          </p:spTgt>
-                                        </p:tgtEl>
-                                        <p:attrNameLst>
-                                          <p:attrName>style.visibility</p:attrName>
-                                        </p:attrNameLst>
-                                      </p:cBhvr>
-                                      <p:to>
-                                        <p:strVal val="visible"/>
-                                      </p:to>
-                                    </p:set>
-                                  </p:childTnLst>
-                                </p:cTn>
-                              </p:par>
-                            </p:childTnLst>
-                          </p:cTn>
-                        </p:par>
-                      </p:childTnLst>
-                    </p:cTn>
-                  </p:par>
-                  <p:par>
-                    <p:cTn id="15" fill="hold">
-                      <p:stCondLst>
-                        <p:cond delay="indefinite"/>
-                      </p:stCondLst>
-                      <p:childTnLst>
-                        <p:par>
-                          <p:cTn id="16" fill="hold">
-                            <p:stCondLst>
-                              <p:cond delay="0"/>
-                            </p:stCondLst>
-                            <p:childTnLst>
-                              <p:par>
-                                <p:cTn id="17" presetID="1" presetClass="entr" presetSubtype="0" fill="hold" grpId="0" nodeType="clickEffect">
-                                  <p:stCondLst>
-                                    <p:cond delay="0"/>
-                                  </p:stCondLst>
-                                  <p:childTnLst>
-                                    <p:set>
-                                      <p:cBhvr>
-                                        <p:cTn id="18" dur="1" fill="hold">
-                                          <p:stCondLst>
-                                            <p:cond delay="0"/>
-                                          </p:stCondLst>
-                                        </p:cTn>
-                                        <p:tgtEl>
-                                          <p:spTgt spid="2">
-                                            <p:txEl>
-                                              <p:pRg st="3" end="3"/>
-                                            </p:txEl>
-                                          </p:spTgt>
-                                        </p:tgtEl>
-                                        <p:attrNameLst>
-                                          <p:attrName>style.visibility</p:attrName>
-                                        </p:attrNameLst>
-                                      </p:cBhvr>
-                                      <p:to>
-                                        <p:strVal val="visible"/>
-                                      </p:to>
-                                    </p:set>
-                                  </p:childTnLst>
-                                </p:cTn>
-                              </p:par>
-                            </p:childTnLst>
-                          </p:cTn>
-                        </p:par>
-                      </p:childTnLst>
-                    </p:cTn>
-                  </p:par>
-                  <p:par>
-                    <p:cTn id="19" fill="hold">
-                      <p:stCondLst>
-                        <p:cond delay="indefinite"/>
-                      </p:stCondLst>
-                      <p:childTnLst>
-                        <p:par>
-                          <p:cTn id="20" fill="hold">
-                            <p:stCondLst>
-                              <p:cond delay="0"/>
-                            </p:stCondLst>
-                            <p:childTnLst>
-                              <p:par>
-                                <p:cTn id="21" presetID="1" presetClass="entr" presetSubtype="0" fill="hold" grpId="0" nodeType="clickEffect">
-                                  <p:stCondLst>
-                                    <p:cond delay="0"/>
-                                  </p:stCondLst>
-                                  <p:childTnLst>
-                                    <p:set>
-                                      <p:cBhvr>
-                                        <p:cTn id="22" dur="1" fill="hold">
-                                          <p:stCondLst>
-                                            <p:cond delay="0"/>
-                                          </p:stCondLst>
-                                        </p:cTn>
-                                        <p:tgtEl>
-                                          <p:spTgt spid="2">
-                                            <p:txEl>
-                                              <p:pRg st="4" end="4"/>
-                                            </p:txEl>
-                                          </p:spTgt>
-                                        </p:tgtEl>
-                                        <p:attrNameLst>
-                                          <p:attrName>style.visibility</p:attrName>
-                                        </p:attrNameLst>
-                                      </p:cBhvr>
-                                      <p:to>
-                                        <p:strVal val="visible"/>
-                                      </p:to>
-                                    </p:set>
-                                  </p:childTnLst>
-                                </p:cTn>
-                              </p:par>
-                            </p:childTnLst>
-                          </p:cTn>
-                        </p:par>
-                      </p:childTnLst>
-                    </p:cTn>
-                  </p:par>
-                  <p:par>
-                    <p:cTn id="23" fill="hold">
-                      <p:stCondLst>
-                        <p:cond delay="indefinite"/>
-                      </p:stCondLst>
-                      <p:childTnLst>
-                        <p:par>
-                          <p:cTn id="24" fill="hold">
-                            <p:stCondLst>
-                              <p:cond delay="0"/>
-                            </p:stCondLst>
-                            <p:childTnLst>
-                              <p:par>
-                                <p:cTn id="25" presetID="1" presetClass="entr" presetSubtype="0" fill="hold" grpId="0" nodeType="clickEffect">
-                                  <p:stCondLst>
-                                    <p:cond delay="0"/>
-                                  </p:stCondLst>
-                                  <p:childTnLst>
-                                    <p:set>
-                                      <p:cBhvr>
-                                        <p:cTn id="26" dur="1" fill="hold">
-                                          <p:stCondLst>
-                                            <p:cond delay="0"/>
-                                          </p:stCondLst>
-                                        </p:cTn>
-                                        <p:tgtEl>
-                                          <p:spTgt spid="2">
-                                            <p:txEl>
-                                              <p:pRg st="5" end="5"/>
-                                            </p:txEl>
-                                          </p:spTgt>
-                                        </p:tgtEl>
-                                        <p:attrNameLst>
-                                          <p:attrName>style.visibility</p:attrName>
-                                        </p:attrNameLst>
-                                      </p:cBhvr>
-                                      <p:to>
-                                        <p:strVal val="visible"/>
-                                      </p:to>
-                                    </p:set>
-                                  </p:childTnLst>
-                                </p:cTn>
-                              </p:par>
-                            </p:childTnLst>
-                          </p:cTn>
-                        </p:par>
-                      </p:childTnLst>
-                    </p:cTn>
-                  </p:par>
-                </p:childTnLst>
-              </p:cTn>
-              <p:prevCondLst>
-                <p:cond evt="onPrev" delay="0">
-                  <p:tgtEl>
-                    <p:sldTgt/>
-                  </p:tgtEl>
-                </p:cond>
-              </p:prevCondLst>
-              <p:nextCondLst>
-                <p:cond evt="onNext" delay="0">
-                  <p:tgtEl>
-                    <p:sldTgt/>
-                  </p:tgtEl>
-                </p:cond>
-              </p:nextCondLst>
-            </p:seq>
-          </p:childTnLst>
-        </p:cTn>
-      </p:par>
-    </p:tnLst>
-    <p:bldLst>
-      <p:bldP spid="2" grpId="0" uiExpand="1" build="p"/>
-    </p:bldLst>
-  </p:timing>
 </p:sld>
 </file>
 
-<file path=ppt/slides/slide3.xml><?xml version="1.0" encoding="utf-8"?>
-<p:sld xmlns:a="http://schemas.openxmlformats.org/drawingml/2006/main" xmlns:r="http://schemas.openxmlformats.org/officeDocument/2006/relationships" xmlns:p="http://schemas.openxmlformats.org/presentationml/2006/main">
-  <p:cSld>
-    <p:spTree>
-      <p:nvGrpSpPr>
-        <p:cNvPr id="1" name="">
-          <a:extLst>
-            <a:ext uri="{FF2B5EF4-FFF2-40B4-BE49-F238E27FC236}">
-              <a16:creationId xmlns:a16="http://schemas.microsoft.com/office/drawing/2014/main" id="{86D1235D-73A1-0B84-0745-6B97432CB074}"/>
-            </a:ext>
-          </a:extLst>
-        </p:cNvPr>
-        <p:cNvGrpSpPr/>
-        <p:nvPr/>
-      </p:nvGrpSpPr>
-      <p:grpSpPr>
-        <a:xfrm>
-          <a:off x="0" y="0"/>
-          <a:ext cx="0" cy="0"/>
-          <a:chOff x="0" y="0"/>
-          <a:chExt cx="0" cy="0"/>
-        </a:xfrm>
-      </p:grpSpPr>
-      <p:sp>
-        <p:nvSpPr>
-          <p:cNvPr id="2" name="Text Placeholder 1">
-            <a:extLst>
-              <a:ext uri="{FF2B5EF4-FFF2-40B4-BE49-F238E27FC236}">
-                <a16:creationId xmlns:a16="http://schemas.microsoft.com/office/drawing/2014/main" id="{44D551BF-43EB-C049-6D3B-4D17D5775294}"/>
-              </a:ext>
-            </a:extLst>
-          </p:cNvPr>
-          <p:cNvSpPr>
-            <a:spLocks noGrp="1"/>
-          </p:cNvSpPr>
-          <p:nvPr>
-            <p:ph type="body" sz="quarter" idx="13"/>
-          </p:nvPr>
-        </p:nvSpPr>
-        <p:spPr>
-          <a:xfrm>
-            <a:off x="255996" y="1271219"/>
-            <a:ext cx="10624338" cy="4142989"/>
-          </a:xfrm>
-        </p:spPr>
-        <p:txBody>
-          <a:bodyPr/>
-          <a:lstStyle/>
-          <a:p>
-            <a:pPr marL="342900" lvl="0" indent="-342900"/>
-            <a:r>
-              <a:rPr lang="en-IN" sz="2400" dirty="0">
-                <a:latin typeface="+mn-lt"/>
-              </a:rPr>
-              <a:t>To develop a Deterministic MCP-Driven AI Agent for ball bearing health monitoring and fault diagnosis. </a:t>
-            </a:r>
-          </a:p>
-          <a:p>
-            <a:pPr marL="342900" lvl="0" indent="-342900"/>
-            <a:r>
-              <a:rPr lang="en-IN" sz="2400" dirty="0">
-                <a:latin typeface="+mn-lt"/>
-              </a:rPr>
-              <a:t>To </a:t>
-            </a:r>
-            <a:r>
-              <a:rPr lang="en-IN" sz="2400" dirty="0" err="1">
-                <a:latin typeface="+mn-lt"/>
-              </a:rPr>
-              <a:t>analyze</a:t>
-            </a:r>
-            <a:r>
-              <a:rPr lang="en-IN" sz="2400" dirty="0">
-                <a:latin typeface="+mn-lt"/>
-              </a:rPr>
-              <a:t> vibration signals and accurately identify different bearing health conditions. </a:t>
-            </a:r>
-          </a:p>
-          <a:p>
-            <a:pPr marL="342900" lvl="0" indent="-342900"/>
-            <a:r>
-              <a:rPr lang="en-IN" sz="2400" dirty="0">
-                <a:latin typeface="+mn-lt"/>
-              </a:rPr>
-              <a:t>To incorporate ISO-based standards and diagnostic principles into the analysis workflow. </a:t>
-            </a:r>
-          </a:p>
-          <a:p>
-            <a:pPr marL="342900" lvl="0" indent="-342900"/>
-            <a:r>
-              <a:rPr lang="en-IN" sz="2400" dirty="0">
-                <a:latin typeface="+mn-lt"/>
-              </a:rPr>
-              <a:t>To provide consistent, explainable, and reproducible fault identification rather than relying solely on probabilistic outputs. </a:t>
-            </a:r>
-          </a:p>
-          <a:p>
-            <a:pPr marL="342900" lvl="0" indent="-342900"/>
-            <a:r>
-              <a:rPr lang="en-IN" sz="2400" dirty="0">
-                <a:latin typeface="+mn-lt"/>
-              </a:rPr>
-              <a:t>To assist maintenance engineers and reliability teams in making informed maintenance decisions. </a:t>
-            </a:r>
-          </a:p>
-          <a:p>
-            <a:pPr marL="342900" lvl="0" indent="-342900"/>
-            <a:r>
-              <a:rPr lang="en-IN" sz="2400" dirty="0">
-                <a:latin typeface="+mn-lt"/>
-              </a:rPr>
-              <a:t>To reduce the risk of unplanned equipment failures, downtime, and unnecessary maintenance.</a:t>
-            </a:r>
-          </a:p>
-          <a:p>
-            <a:pPr marL="0" indent="0">
-              <a:lnSpc>
-                <a:spcPct val="150000"/>
-              </a:lnSpc>
-              <a:buNone/>
-            </a:pPr>
-            <a:endParaRPr lang="en-US" sz="2400" b="0" dirty="0">
-              <a:solidFill>
-                <a:srgbClr val="5583D1"/>
-              </a:solidFill>
-              <a:latin typeface="+mn-lt"/>
-            </a:endParaRPr>
-          </a:p>
-        </p:txBody>
-      </p:sp>
-      <p:sp>
-        <p:nvSpPr>
-          <p:cNvPr id="3" name="TextBox 2">
-            <a:extLst>
-              <a:ext uri="{FF2B5EF4-FFF2-40B4-BE49-F238E27FC236}">
-                <a16:creationId xmlns:a16="http://schemas.microsoft.com/office/drawing/2014/main" id="{72FF40D3-B05A-88C3-591F-882A93FC9918}"/>
-              </a:ext>
-            </a:extLst>
-          </p:cNvPr>
-          <p:cNvSpPr txBox="1"/>
-          <p:nvPr/>
-        </p:nvSpPr>
-        <p:spPr>
-          <a:xfrm>
-            <a:off x="255996" y="502545"/>
-            <a:ext cx="10624338" cy="646331"/>
-          </a:xfrm>
-          <a:prstGeom prst="rect">
-            <a:avLst/>
-          </a:prstGeom>
-          <a:noFill/>
-        </p:spPr>
-        <p:txBody>
-          <a:bodyPr wrap="square" rtlCol="0">
-            <a:spAutoFit/>
-          </a:bodyPr>
-          <a:lstStyle/>
-          <a:p>
-            <a:pPr marL="0" marR="0" lvl="0" indent="0" algn="l" defTabSz="914400" rtl="0" eaLnBrk="1" fontAlgn="auto" latinLnBrk="0" hangingPunct="1">
-              <a:lnSpc>
-                <a:spcPct val="100000"/>
-              </a:lnSpc>
-              <a:spcBef>
-                <a:spcPts val="0"/>
-              </a:spcBef>
-              <a:spcAft>
-                <a:spcPts val="0"/>
-              </a:spcAft>
-              <a:buClrTx/>
-              <a:buSzTx/>
-              <a:buFontTx/>
-              <a:buNone/>
-              <a:tabLst/>
-              <a:defRPr/>
-            </a:pPr>
-            <a:r>
-              <a:rPr kumimoji="0" lang="en-US" sz="3600" b="1" i="0" u="none" strike="noStrike" kern="1200" cap="none" spc="0" normalizeH="0" baseline="0" noProof="0" dirty="0">
-                <a:ln>
-                  <a:noFill/>
-                </a:ln>
-                <a:solidFill>
-                  <a:srgbClr val="5B9BD5">
-                    <a:lumMod val="50000"/>
-                  </a:srgbClr>
-                </a:solidFill>
-                <a:effectLst/>
-                <a:uLnTx/>
-                <a:uFillTx/>
-                <a:latin typeface="Calibri" panose="020F0502020204030204"/>
-                <a:ea typeface="+mn-ea"/>
-                <a:cs typeface="+mn-cs"/>
-              </a:rPr>
-              <a:t>Objective</a:t>
-            </a:r>
-          </a:p>
-        </p:txBody>
-      </p:sp>
-      <p:cxnSp>
-        <p:nvCxnSpPr>
-          <p:cNvPr id="5" name="Straight Connector 4">
-            <a:extLst>
-              <a:ext uri="{FF2B5EF4-FFF2-40B4-BE49-F238E27FC236}">
-                <a16:creationId xmlns:a16="http://schemas.microsoft.com/office/drawing/2014/main" id="{12740D4D-2363-70E1-0E6E-1BDDA8C33C87}"/>
-              </a:ext>
-            </a:extLst>
-          </p:cNvPr>
-          <p:cNvCxnSpPr>
-            <a:cxnSpLocks/>
-          </p:cNvCxnSpPr>
-          <p:nvPr/>
-        </p:nvCxnSpPr>
-        <p:spPr>
-          <a:xfrm>
-            <a:off x="221274" y="1191756"/>
-            <a:ext cx="7305799" cy="0"/>
-          </a:xfrm>
-          <a:prstGeom prst="line">
-            <a:avLst/>
-          </a:prstGeom>
-          <a:ln w="28575">
-            <a:solidFill>
-              <a:schemeClr val="accent6"/>
-            </a:solidFill>
-          </a:ln>
-        </p:spPr>
-        <p:style>
-          <a:lnRef idx="1">
-            <a:schemeClr val="accent1"/>
-          </a:lnRef>
-          <a:fillRef idx="0">
-            <a:schemeClr val="accent1"/>
-          </a:fillRef>
-          <a:effectRef idx="0">
-            <a:schemeClr val="accent1"/>
-          </a:effectRef>
-          <a:fontRef idx="minor">
-            <a:schemeClr val="tx1"/>
-          </a:fontRef>
-        </p:style>
-      </p:cxnSp>
-      <p:sp>
-        <p:nvSpPr>
-          <p:cNvPr id="4" name="TextBox 3">
-            <a:extLst>
-              <a:ext uri="{FF2B5EF4-FFF2-40B4-BE49-F238E27FC236}">
-                <a16:creationId xmlns:a16="http://schemas.microsoft.com/office/drawing/2014/main" id="{E4452DD5-D934-4955-F39B-2109AC72692F}"/>
-              </a:ext>
-            </a:extLst>
-          </p:cNvPr>
-          <p:cNvSpPr txBox="1"/>
-          <p:nvPr/>
-        </p:nvSpPr>
-        <p:spPr>
-          <a:xfrm>
-            <a:off x="4931229" y="57036"/>
-            <a:ext cx="7260771" cy="369332"/>
-          </a:xfrm>
-          <a:prstGeom prst="rect">
-            <a:avLst/>
-          </a:prstGeom>
-          <a:noFill/>
-        </p:spPr>
-        <p:txBody>
-          <a:bodyPr wrap="square" rtlCol="0">
-            <a:spAutoFit/>
-          </a:bodyPr>
-          <a:lstStyle/>
-          <a:p>
-            <a:pPr lvl="0" algn="ctr">
-              <a:defRPr/>
-            </a:pPr>
-            <a:r>
-              <a:rPr lang="en-GB" b="1" dirty="0">
-                <a:solidFill>
-                  <a:prstClr val="white"/>
-                </a:solidFill>
-                <a:cs typeface="Calibri" panose="020F0502020204030204" pitchFamily="34" charset="0"/>
-              </a:rPr>
-              <a:t>Deterministic MCP-Driven AI Agents for Ball Bearing Vibration Diagnostics</a:t>
-            </a:r>
-            <a:endParaRPr lang="en-US" b="1" dirty="0">
-              <a:solidFill>
-                <a:prstClr val="white"/>
-              </a:solidFill>
-              <a:cs typeface="Calibri" panose="020F0502020204030204" pitchFamily="34" charset="0"/>
-            </a:endParaRPr>
-          </a:p>
-        </p:txBody>
-      </p:sp>
-    </p:spTree>
-    <p:extLst>
-      <p:ext uri="{BB962C8B-B14F-4D97-AF65-F5344CB8AC3E}">
-        <p14:creationId xmlns:p14="http://schemas.microsoft.com/office/powerpoint/2010/main" val="1739450533"/>
-      </p:ext>
-    </p:extLst>
-  </p:cSld>
-  <p:clrMapOvr>
-    <a:masterClrMapping/>
-  </p:clrMapOvr>
-  <mc:AlternateContent xmlns:mc="http://schemas.openxmlformats.org/markup-compatibility/2006" xmlns:p14="http://schemas.microsoft.com/office/powerpoint/2010/main">
-    <mc:Choice Requires="p14">
-      <p:transition spd="med" p14:dur="700">
-        <p:fade/>
-      </p:transition>
-    </mc:Choice>
-    <mc:Fallback xmlns="">
-      <p:transition spd="med">
-        <p:fade/>
-      </p:transition>
-    </mc:Fallback>
-  </mc:AlternateContent>
-  <p:timing>
-    <p:tnLst>
-      <p:par>
-        <p:cTn id="1" dur="indefinite" restart="never" nodeType="tmRoot">
-          <p:childTnLst>
-            <p:seq concurrent="1" nextAc="seek">
-              <p:cTn id="2" dur="indefinite" nodeType="mainSeq">
-                <p:childTnLst>
-                  <p:par>
-                    <p:cTn id="3" fill="hold">
-                      <p:stCondLst>
-                        <p:cond delay="indefinite"/>
-                      </p:stCondLst>
-                      <p:childTnLst>
-                        <p:par>
-                          <p:cTn id="4" fill="hold">
-                            <p:stCondLst>
-                              <p:cond delay="0"/>
-                            </p:stCondLst>
-                            <p:childTnLst>
-                              <p:par>
-                                <p:cTn id="5" presetID="1" presetClass="entr" presetSubtype="0" fill="hold" grpId="0" nodeType="clickEffect">
-                                  <p:stCondLst>
-                                    <p:cond delay="0"/>
-                                  </p:stCondLst>
-                                  <p:childTnLst>
-                                    <p:set>
-                                      <p:cBhvr>
-                                        <p:cTn id="6" dur="1" fill="hold">
-                                          <p:stCondLst>
-                                            <p:cond delay="0"/>
-                                          </p:stCondLst>
-                                        </p:cTn>
-                                        <p:tgtEl>
-                                          <p:spTgt spid="2">
-                                            <p:txEl>
-                                              <p:pRg st="0" end="0"/>
-                                            </p:txEl>
-                                          </p:spTgt>
-                                        </p:tgtEl>
-                                        <p:attrNameLst>
-                                          <p:attrName>style.visibility</p:attrName>
-                                        </p:attrNameLst>
-                                      </p:cBhvr>
-                                      <p:to>
-                                        <p:strVal val="visible"/>
-                                      </p:to>
-                                    </p:set>
-                                  </p:childTnLst>
-                                </p:cTn>
-                              </p:par>
-                            </p:childTnLst>
-                          </p:cTn>
-                        </p:par>
-                      </p:childTnLst>
-                    </p:cTn>
-                  </p:par>
-                  <p:par>
-                    <p:cTn id="7" fill="hold">
-                      <p:stCondLst>
-                        <p:cond delay="indefinite"/>
-                      </p:stCondLst>
-                      <p:childTnLst>
-                        <p:par>
-                          <p:cTn id="8" fill="hold">
-                            <p:stCondLst>
-                              <p:cond delay="0"/>
-                            </p:stCondLst>
-                            <p:childTnLst>
-                              <p:par>
-                                <p:cTn id="9" presetID="1" presetClass="entr" presetSubtype="0" fill="hold" grpId="0" nodeType="clickEffect">
-                                  <p:stCondLst>
-                                    <p:cond delay="0"/>
-                                  </p:stCondLst>
-                                  <p:childTnLst>
-                                    <p:set>
-                                      <p:cBhvr>
-                                        <p:cTn id="10" dur="1" fill="hold">
-                                          <p:stCondLst>
-                                            <p:cond delay="0"/>
-                                          </p:stCondLst>
-                                        </p:cTn>
-                                        <p:tgtEl>
-                                          <p:spTgt spid="2">
-                                            <p:txEl>
-                                              <p:pRg st="1" end="1"/>
-                                            </p:txEl>
-                                          </p:spTgt>
-                                        </p:tgtEl>
-                                        <p:attrNameLst>
-                                          <p:attrName>style.visibility</p:attrName>
-                                        </p:attrNameLst>
-                                      </p:cBhvr>
-                                      <p:to>
-                                        <p:strVal val="visible"/>
-                                      </p:to>
-                                    </p:set>
-                                  </p:childTnLst>
-                                </p:cTn>
-                              </p:par>
-                            </p:childTnLst>
-                          </p:cTn>
-                        </p:par>
-                      </p:childTnLst>
-                    </p:cTn>
-                  </p:par>
-                  <p:par>
-                    <p:cTn id="11" fill="hold">
-                      <p:stCondLst>
-                        <p:cond delay="indefinite"/>
-                      </p:stCondLst>
-                      <p:childTnLst>
-                        <p:par>
-                          <p:cTn id="12" fill="hold">
-                            <p:stCondLst>
-                              <p:cond delay="0"/>
-                            </p:stCondLst>
-                            <p:childTnLst>
-                              <p:par>
-                                <p:cTn id="13" presetID="1" presetClass="entr" presetSubtype="0" fill="hold" grpId="0" nodeType="clickEffect">
-                                  <p:stCondLst>
-                                    <p:cond delay="0"/>
-                                  </p:stCondLst>
-                                  <p:childTnLst>
-                                    <p:set>
-                                      <p:cBhvr>
-                                        <p:cTn id="14" dur="1" fill="hold">
-                                          <p:stCondLst>
-                                            <p:cond delay="0"/>
-                                          </p:stCondLst>
-                                        </p:cTn>
-                                        <p:tgtEl>
-                                          <p:spTgt spid="2">
-                                            <p:txEl>
-                                              <p:pRg st="2" end="2"/>
-                                            </p:txEl>
-                                          </p:spTgt>
-                                        </p:tgtEl>
-                                        <p:attrNameLst>
-                                          <p:attrName>style.visibility</p:attrName>
-                                        </p:attrNameLst>
-                                      </p:cBhvr>
-                                      <p:to>
-                                        <p:strVal val="visible"/>
-                                      </p:to>
-                                    </p:set>
-                                  </p:childTnLst>
-                                </p:cTn>
-                              </p:par>
-                            </p:childTnLst>
-                          </p:cTn>
-                        </p:par>
-                      </p:childTnLst>
-                    </p:cTn>
-                  </p:par>
-                  <p:par>
-                    <p:cTn id="15" fill="hold">
-                      <p:stCondLst>
-                        <p:cond delay="indefinite"/>
-                      </p:stCondLst>
-                      <p:childTnLst>
-                        <p:par>
-                          <p:cTn id="16" fill="hold">
-                            <p:stCondLst>
-                              <p:cond delay="0"/>
-                            </p:stCondLst>
-                            <p:childTnLst>
-                              <p:par>
-                                <p:cTn id="17" presetID="1" presetClass="entr" presetSubtype="0" fill="hold" grpId="0" nodeType="clickEffect">
-                                  <p:stCondLst>
-                                    <p:cond delay="0"/>
-                                  </p:stCondLst>
-                                  <p:childTnLst>
-                                    <p:set>
-                                      <p:cBhvr>
-                                        <p:cTn id="18" dur="1" fill="hold">
-                                          <p:stCondLst>
-                                            <p:cond delay="0"/>
-                                          </p:stCondLst>
-                                        </p:cTn>
-                                        <p:tgtEl>
-                                          <p:spTgt spid="2">
-                                            <p:txEl>
-                                              <p:pRg st="3" end="3"/>
-                                            </p:txEl>
-                                          </p:spTgt>
-                                        </p:tgtEl>
-                                        <p:attrNameLst>
-                                          <p:attrName>style.visibility</p:attrName>
-                                        </p:attrNameLst>
-                                      </p:cBhvr>
-                                      <p:to>
-                                        <p:strVal val="visible"/>
-                                      </p:to>
-                                    </p:set>
-                                  </p:childTnLst>
-                                </p:cTn>
-                              </p:par>
-                            </p:childTnLst>
-                          </p:cTn>
-                        </p:par>
-                      </p:childTnLst>
-                    </p:cTn>
-                  </p:par>
-                  <p:par>
-                    <p:cTn id="19" fill="hold">
-                      <p:stCondLst>
-                        <p:cond delay="indefinite"/>
-                      </p:stCondLst>
-                      <p:childTnLst>
-                        <p:par>
-                          <p:cTn id="20" fill="hold">
-                            <p:stCondLst>
-                              <p:cond delay="0"/>
-                            </p:stCondLst>
-                            <p:childTnLst>
-                              <p:par>
-                                <p:cTn id="21" presetID="1" presetClass="entr" presetSubtype="0" fill="hold" grpId="0" nodeType="clickEffect">
-                                  <p:stCondLst>
-                                    <p:cond delay="0"/>
-                                  </p:stCondLst>
-                                  <p:childTnLst>
-                                    <p:set>
-                                      <p:cBhvr>
-                                        <p:cTn id="22" dur="1" fill="hold">
-                                          <p:stCondLst>
-                                            <p:cond delay="0"/>
-                                          </p:stCondLst>
-                                        </p:cTn>
-                                        <p:tgtEl>
-                                          <p:spTgt spid="2">
-                                            <p:txEl>
-                                              <p:pRg st="4" end="4"/>
-                                            </p:txEl>
-                                          </p:spTgt>
-                                        </p:tgtEl>
-                                        <p:attrNameLst>
-                                          <p:attrName>style.visibility</p:attrName>
-                                        </p:attrNameLst>
-                                      </p:cBhvr>
-                                      <p:to>
-                                        <p:strVal val="visible"/>
-                                      </p:to>
-                                    </p:set>
-                                  </p:childTnLst>
-                                </p:cTn>
-                              </p:par>
-                            </p:childTnLst>
-                          </p:cTn>
-                        </p:par>
-                      </p:childTnLst>
-                    </p:cTn>
-                  </p:par>
-                  <p:par>
-                    <p:cTn id="23" fill="hold">
-                      <p:stCondLst>
-                        <p:cond delay="indefinite"/>
-                      </p:stCondLst>
-                      <p:childTnLst>
-                        <p:par>
-                          <p:cTn id="24" fill="hold">
-                            <p:stCondLst>
-                              <p:cond delay="0"/>
-                            </p:stCondLst>
-                            <p:childTnLst>
-                              <p:par>
-                                <p:cTn id="25" presetID="1" presetClass="entr" presetSubtype="0" fill="hold" grpId="0" nodeType="clickEffect">
-                                  <p:stCondLst>
-                                    <p:cond delay="0"/>
-                                  </p:stCondLst>
-                                  <p:childTnLst>
-                                    <p:set>
-                                      <p:cBhvr>
-                                        <p:cTn id="26" dur="1" fill="hold">
-                                          <p:stCondLst>
-                                            <p:cond delay="0"/>
-                                          </p:stCondLst>
-                                        </p:cTn>
-                                        <p:tgtEl>
-                                          <p:spTgt spid="2">
-                                            <p:txEl>
-                                              <p:pRg st="5" end="5"/>
-                                            </p:txEl>
-                                          </p:spTgt>
-                                        </p:tgtEl>
-                                        <p:attrNameLst>
-                                          <p:attrName>style.visibility</p:attrName>
-                                        </p:attrNameLst>
-                                      </p:cBhvr>
-                                      <p:to>
-                                        <p:strVal val="visible"/>
-                                      </p:to>
-                                    </p:set>
-                                  </p:childTnLst>
-                                </p:cTn>
-                              </p:par>
-                            </p:childTnLst>
-                          </p:cTn>
-                        </p:par>
-                      </p:childTnLst>
-                    </p:cTn>
-                  </p:par>
-                </p:childTnLst>
-              </p:cTn>
-              <p:prevCondLst>
-                <p:cond evt="onPrev" delay="0">
-                  <p:tgtEl>
-                    <p:sldTgt/>
-                  </p:tgtEl>
-                </p:cond>
-              </p:prevCondLst>
-              <p:nextCondLst>
-                <p:cond evt="onNext" delay="0">
-                  <p:tgtEl>
-                    <p:sldTgt/>
-                  </p:tgtEl>
-                </p:cond>
-              </p:nextCondLst>
-            </p:seq>
-          </p:childTnLst>
-        </p:cTn>
-      </p:par>
-    </p:tnLst>
-    <p:bldLst>
-      <p:bldP spid="2" grpId="0" uiExpand="1" build="p"/>
-    </p:bldLst>
-  </p:timing>
-</p:sld>
-</file>
-
-<file path=ppt/slides/slide4.xml><?xml version="1.0" encoding="utf-8"?>
-<p:sld xmlns:a="http://schemas.openxmlformats.org/drawingml/2006/main" xmlns:r="http://schemas.openxmlformats.org/officeDocument/2006/relationships" xmlns:p="http://schemas.openxmlformats.org/presentationml/2006/main">
-  <p:cSld>
-    <p:spTree>
-      <p:nvGrpSpPr>
-        <p:cNvPr id="1" name="">
-          <a:extLst>
-            <a:ext uri="{FF2B5EF4-FFF2-40B4-BE49-F238E27FC236}">
-              <a16:creationId xmlns:a16="http://schemas.microsoft.com/office/drawing/2014/main" id="{CBE2D7CD-C158-6FC1-06C7-09444D2DE02B}"/>
-            </a:ext>
-          </a:extLst>
-        </p:cNvPr>
-        <p:cNvGrpSpPr/>
-        <p:nvPr/>
-      </p:nvGrpSpPr>
-      <p:grpSpPr>
-        <a:xfrm>
-          <a:off x="0" y="0"/>
-          <a:ext cx="0" cy="0"/>
-          <a:chOff x="0" y="0"/>
-          <a:chExt cx="0" cy="0"/>
-        </a:xfrm>
-      </p:grpSpPr>
-      <p:sp>
-        <p:nvSpPr>
-          <p:cNvPr id="2" name="Text Placeholder 1">
-            <a:extLst>
-              <a:ext uri="{FF2B5EF4-FFF2-40B4-BE49-F238E27FC236}">
-                <a16:creationId xmlns:a16="http://schemas.microsoft.com/office/drawing/2014/main" id="{D325C8EF-A5DD-AB22-0372-51B9ABE63526}"/>
-              </a:ext>
-            </a:extLst>
-          </p:cNvPr>
-          <p:cNvSpPr>
-            <a:spLocks noGrp="1"/>
-          </p:cNvSpPr>
-          <p:nvPr>
-            <p:ph type="body" sz="quarter" idx="13"/>
-          </p:nvPr>
-        </p:nvSpPr>
-        <p:spPr>
-          <a:xfrm>
-            <a:off x="255996" y="1271219"/>
-            <a:ext cx="10624338" cy="4142989"/>
-          </a:xfrm>
-        </p:spPr>
-        <p:txBody>
-          <a:bodyPr/>
-          <a:lstStyle/>
-          <a:p>
-            <a:pPr marL="342900" lvl="0" indent="-342900"/>
-            <a:r>
-              <a:rPr lang="en-IN" sz="2400" dirty="0">
-                <a:latin typeface="+mn-lt"/>
-              </a:rPr>
-              <a:t>Analysis: Signal preprocessing, feature extraction, condition assessment, and bearing fault identification. </a:t>
-            </a:r>
-          </a:p>
-          <a:p>
-            <a:pPr marL="342900" lvl="0" indent="-342900"/>
-            <a:r>
-              <a:rPr lang="en-IN" sz="2400" dirty="0">
-                <a:latin typeface="+mn-lt"/>
-              </a:rPr>
-              <a:t>Fault Diagnosis: Classification of bearing health conditions based on characteristic vibration patterns and degradation </a:t>
-            </a:r>
-            <a:r>
-              <a:rPr lang="en-IN" sz="2400" dirty="0" err="1">
-                <a:latin typeface="+mn-lt"/>
-              </a:rPr>
-              <a:t>behavior</a:t>
-            </a:r>
-            <a:r>
-              <a:rPr lang="en-IN" sz="2400" dirty="0">
-                <a:latin typeface="+mn-lt"/>
-              </a:rPr>
-              <a:t>. </a:t>
-            </a:r>
-          </a:p>
-          <a:p>
-            <a:pPr marL="342900" lvl="0" indent="-342900"/>
-            <a:r>
-              <a:rPr lang="en-IN" sz="2400" dirty="0">
-                <a:latin typeface="+mn-lt"/>
-              </a:rPr>
-              <a:t>AI Agent: Development of a deterministic MCP-based workflow for structured and repeatable diagnostic reasoning. </a:t>
-            </a:r>
-          </a:p>
-          <a:p>
-            <a:pPr marL="342900" lvl="0" indent="-342900"/>
-            <a:r>
-              <a:rPr lang="en-IN" sz="2400" dirty="0">
-                <a:latin typeface="+mn-lt"/>
-              </a:rPr>
-              <a:t>Standards: Use of relevant ISO standards for vibration measurement, evaluation, and machine condition monitoring. </a:t>
-            </a:r>
-          </a:p>
-          <a:p>
-            <a:pPr marL="342900" lvl="0" indent="-342900"/>
-            <a:r>
-              <a:rPr lang="en-IN" sz="2400" dirty="0">
-                <a:latin typeface="+mn-lt"/>
-              </a:rPr>
-              <a:t>Output: A clear diagnostic result with an explainable and reproducible basis for the identified bearing condition. </a:t>
-            </a:r>
-          </a:p>
-          <a:p>
-            <a:pPr marL="342900" lvl="0" indent="-342900"/>
-            <a:r>
-              <a:rPr lang="en-IN" sz="2400" dirty="0">
-                <a:latin typeface="+mn-lt"/>
-              </a:rPr>
-              <a:t>Application: Supporting predictive maintenance and reliability-</a:t>
-            </a:r>
-            <a:r>
-              <a:rPr lang="en-IN" sz="2400" dirty="0" err="1">
-                <a:latin typeface="+mn-lt"/>
-              </a:rPr>
-              <a:t>centered</a:t>
-            </a:r>
-            <a:r>
-              <a:rPr lang="en-IN" sz="2400" dirty="0">
-                <a:latin typeface="+mn-lt"/>
-              </a:rPr>
-              <a:t> decision-making for rotating machinery.</a:t>
-            </a:r>
-          </a:p>
-          <a:p>
-            <a:pPr marL="0" indent="0">
-              <a:lnSpc>
-                <a:spcPct val="150000"/>
-              </a:lnSpc>
-              <a:buNone/>
-            </a:pPr>
-            <a:endParaRPr lang="en-US" sz="2400" b="0" dirty="0">
-              <a:solidFill>
-                <a:srgbClr val="5583D1"/>
-              </a:solidFill>
-              <a:latin typeface="+mn-lt"/>
-            </a:endParaRPr>
-          </a:p>
-        </p:txBody>
-      </p:sp>
-      <p:sp>
-        <p:nvSpPr>
-          <p:cNvPr id="3" name="TextBox 2">
-            <a:extLst>
-              <a:ext uri="{FF2B5EF4-FFF2-40B4-BE49-F238E27FC236}">
-                <a16:creationId xmlns:a16="http://schemas.microsoft.com/office/drawing/2014/main" id="{CB15F4B8-EED0-F7BE-96C7-D7AAE989A251}"/>
-              </a:ext>
-            </a:extLst>
-          </p:cNvPr>
-          <p:cNvSpPr txBox="1"/>
-          <p:nvPr/>
-        </p:nvSpPr>
-        <p:spPr>
-          <a:xfrm>
-            <a:off x="255996" y="502545"/>
-            <a:ext cx="10624338" cy="646331"/>
-          </a:xfrm>
-          <a:prstGeom prst="rect">
-            <a:avLst/>
-          </a:prstGeom>
-          <a:noFill/>
-        </p:spPr>
-        <p:txBody>
-          <a:bodyPr wrap="square" rtlCol="0">
-            <a:spAutoFit/>
-          </a:bodyPr>
-          <a:lstStyle/>
-          <a:p>
-            <a:pPr marL="0" marR="0" lvl="0" indent="0" algn="l" defTabSz="914400" rtl="0" eaLnBrk="1" fontAlgn="auto" latinLnBrk="0" hangingPunct="1">
-              <a:lnSpc>
-                <a:spcPct val="100000"/>
-              </a:lnSpc>
-              <a:spcBef>
-                <a:spcPts val="0"/>
-              </a:spcBef>
-              <a:spcAft>
-                <a:spcPts val="0"/>
-              </a:spcAft>
-              <a:buClrTx/>
-              <a:buSzTx/>
-              <a:buFontTx/>
-              <a:buNone/>
-              <a:tabLst/>
-              <a:defRPr/>
-            </a:pPr>
-            <a:r>
-              <a:rPr kumimoji="0" lang="en-US" sz="3600" b="1" i="0" u="none" strike="noStrike" kern="1200" cap="none" spc="0" normalizeH="0" baseline="0" noProof="0" dirty="0">
-                <a:ln>
-                  <a:noFill/>
-                </a:ln>
-                <a:solidFill>
-                  <a:srgbClr val="5B9BD5">
-                    <a:lumMod val="50000"/>
-                  </a:srgbClr>
-                </a:solidFill>
-                <a:effectLst/>
-                <a:uLnTx/>
-                <a:uFillTx/>
-                <a:latin typeface="Calibri" panose="020F0502020204030204"/>
-                <a:ea typeface="+mn-ea"/>
-                <a:cs typeface="+mn-cs"/>
-              </a:rPr>
-              <a:t>Scope</a:t>
-            </a:r>
-          </a:p>
-        </p:txBody>
-      </p:sp>
-      <p:cxnSp>
-        <p:nvCxnSpPr>
-          <p:cNvPr id="5" name="Straight Connector 4">
-            <a:extLst>
-              <a:ext uri="{FF2B5EF4-FFF2-40B4-BE49-F238E27FC236}">
-                <a16:creationId xmlns:a16="http://schemas.microsoft.com/office/drawing/2014/main" id="{5A882B44-FCE4-BF93-E951-46CF2238FB74}"/>
-              </a:ext>
-            </a:extLst>
-          </p:cNvPr>
-          <p:cNvCxnSpPr>
-            <a:cxnSpLocks/>
-          </p:cNvCxnSpPr>
-          <p:nvPr/>
-        </p:nvCxnSpPr>
-        <p:spPr>
-          <a:xfrm>
-            <a:off x="221274" y="1191756"/>
-            <a:ext cx="7305799" cy="0"/>
-          </a:xfrm>
-          <a:prstGeom prst="line">
-            <a:avLst/>
-          </a:prstGeom>
-          <a:ln w="28575">
-            <a:solidFill>
-              <a:schemeClr val="accent6"/>
-            </a:solidFill>
-          </a:ln>
-        </p:spPr>
-        <p:style>
-          <a:lnRef idx="1">
-            <a:schemeClr val="accent1"/>
-          </a:lnRef>
-          <a:fillRef idx="0">
-            <a:schemeClr val="accent1"/>
-          </a:fillRef>
-          <a:effectRef idx="0">
-            <a:schemeClr val="accent1"/>
-          </a:effectRef>
-          <a:fontRef idx="minor">
-            <a:schemeClr val="tx1"/>
-          </a:fontRef>
-        </p:style>
-      </p:cxnSp>
-      <p:sp>
-        <p:nvSpPr>
-          <p:cNvPr id="4" name="TextBox 3">
-            <a:extLst>
-              <a:ext uri="{FF2B5EF4-FFF2-40B4-BE49-F238E27FC236}">
-                <a16:creationId xmlns:a16="http://schemas.microsoft.com/office/drawing/2014/main" id="{6CE164B1-01DD-BF3B-88E8-DF2DEDBFA9EB}"/>
-              </a:ext>
-            </a:extLst>
-          </p:cNvPr>
-          <p:cNvSpPr txBox="1"/>
-          <p:nvPr/>
-        </p:nvSpPr>
-        <p:spPr>
-          <a:xfrm>
-            <a:off x="4898571" y="57036"/>
-            <a:ext cx="7293429" cy="369332"/>
-          </a:xfrm>
-          <a:prstGeom prst="rect">
-            <a:avLst/>
-          </a:prstGeom>
-          <a:noFill/>
-        </p:spPr>
-        <p:txBody>
-          <a:bodyPr wrap="square" rtlCol="0">
-            <a:spAutoFit/>
-          </a:bodyPr>
-          <a:lstStyle/>
-          <a:p>
-            <a:pPr lvl="0" algn="ctr">
-              <a:defRPr/>
-            </a:pPr>
-            <a:r>
-              <a:rPr lang="en-GB" b="1" dirty="0">
-                <a:solidFill>
-                  <a:prstClr val="white"/>
-                </a:solidFill>
-                <a:cs typeface="Calibri" panose="020F0502020204030204" pitchFamily="34" charset="0"/>
-              </a:rPr>
-              <a:t>Deterministic MCP-Driven AI Agents for Ball Bearing Vibration Diagnostics</a:t>
-            </a:r>
-            <a:endParaRPr lang="en-US" b="1" dirty="0">
-              <a:solidFill>
-                <a:prstClr val="white"/>
-              </a:solidFill>
-              <a:cs typeface="Calibri" panose="020F0502020204030204" pitchFamily="34" charset="0"/>
-            </a:endParaRPr>
-          </a:p>
-        </p:txBody>
-      </p:sp>
-    </p:spTree>
-    <p:extLst>
-      <p:ext uri="{BB962C8B-B14F-4D97-AF65-F5344CB8AC3E}">
-        <p14:creationId xmlns:p14="http://schemas.microsoft.com/office/powerpoint/2010/main" val="2034681921"/>
-      </p:ext>
-    </p:extLst>
-  </p:cSld>
-  <p:clrMapOvr>
-    <a:masterClrMapping/>
-  </p:clrMapOvr>
-  <mc:AlternateContent xmlns:mc="http://schemas.openxmlformats.org/markup-compatibility/2006" xmlns:p14="http://schemas.microsoft.com/office/powerpoint/2010/main">
-    <mc:Choice Requires="p14">
-      <p:transition spd="med" p14:dur="700">
-        <p:fade/>
-      </p:transition>
-    </mc:Choice>
-    <mc:Fallback xmlns="">
-      <p:transition spd="med">
-        <p:fade/>
-      </p:transition>
-    </mc:Fallback>
-  </mc:AlternateContent>
-  <p:timing>
-    <p:tnLst>
-      <p:par>
-        <p:cTn id="1" dur="indefinite" restart="never" nodeType="tmRoot">
-          <p:childTnLst>
-            <p:seq concurrent="1" nextAc="seek">
-              <p:cTn id="2" dur="indefinite" nodeType="mainSeq">
-                <p:childTnLst>
-                  <p:par>
-                    <p:cTn id="3" fill="hold">
-                      <p:stCondLst>
-                        <p:cond delay="indefinite"/>
-                      </p:stCondLst>
-                      <p:childTnLst>
-                        <p:par>
-                          <p:cTn id="4" fill="hold">
-                            <p:stCondLst>
-                              <p:cond delay="0"/>
-                            </p:stCondLst>
-                            <p:childTnLst>
-                              <p:par>
-                                <p:cTn id="5" presetID="1" presetClass="entr" presetSubtype="0" fill="hold" grpId="0" nodeType="clickEffect">
-                                  <p:stCondLst>
-                                    <p:cond delay="0"/>
-                                  </p:stCondLst>
-                                  <p:childTnLst>
-                                    <p:set>
-                                      <p:cBhvr>
-                                        <p:cTn id="6" dur="1" fill="hold">
-                                          <p:stCondLst>
-                                            <p:cond delay="0"/>
-                                          </p:stCondLst>
-                                        </p:cTn>
-                                        <p:tgtEl>
-                                          <p:spTgt spid="2">
-                                            <p:txEl>
-                                              <p:pRg st="0" end="0"/>
-                                            </p:txEl>
-                                          </p:spTgt>
-                                        </p:tgtEl>
-                                        <p:attrNameLst>
-                                          <p:attrName>style.visibility</p:attrName>
-                                        </p:attrNameLst>
-                                      </p:cBhvr>
-                                      <p:to>
-                                        <p:strVal val="visible"/>
-                                      </p:to>
-                                    </p:set>
-                                  </p:childTnLst>
-                                </p:cTn>
-                              </p:par>
-                            </p:childTnLst>
-                          </p:cTn>
-                        </p:par>
-                      </p:childTnLst>
-                    </p:cTn>
-                  </p:par>
-                  <p:par>
-                    <p:cTn id="7" fill="hold">
-                      <p:stCondLst>
-                        <p:cond delay="indefinite"/>
-                      </p:stCondLst>
-                      <p:childTnLst>
-                        <p:par>
-                          <p:cTn id="8" fill="hold">
-                            <p:stCondLst>
-                              <p:cond delay="0"/>
-                            </p:stCondLst>
-                            <p:childTnLst>
-                              <p:par>
-                                <p:cTn id="9" presetID="1" presetClass="entr" presetSubtype="0" fill="hold" grpId="0" nodeType="clickEffect">
-                                  <p:stCondLst>
-                                    <p:cond delay="0"/>
-                                  </p:stCondLst>
-                                  <p:childTnLst>
-                                    <p:set>
-                                      <p:cBhvr>
-                                        <p:cTn id="10" dur="1" fill="hold">
-                                          <p:stCondLst>
-                                            <p:cond delay="0"/>
-                                          </p:stCondLst>
-                                        </p:cTn>
-                                        <p:tgtEl>
-                                          <p:spTgt spid="2">
-                                            <p:txEl>
-                                              <p:pRg st="1" end="1"/>
-                                            </p:txEl>
-                                          </p:spTgt>
-                                        </p:tgtEl>
-                                        <p:attrNameLst>
-                                          <p:attrName>style.visibility</p:attrName>
-                                        </p:attrNameLst>
-                                      </p:cBhvr>
-                                      <p:to>
-                                        <p:strVal val="visible"/>
-                                      </p:to>
-                                    </p:set>
-                                  </p:childTnLst>
-                                </p:cTn>
-                              </p:par>
-                            </p:childTnLst>
-                          </p:cTn>
-                        </p:par>
-                      </p:childTnLst>
-                    </p:cTn>
-                  </p:par>
-                  <p:par>
-                    <p:cTn id="11" fill="hold">
-                      <p:stCondLst>
-                        <p:cond delay="indefinite"/>
-                      </p:stCondLst>
-                      <p:childTnLst>
-                        <p:par>
-                          <p:cTn id="12" fill="hold">
-                            <p:stCondLst>
-                              <p:cond delay="0"/>
-                            </p:stCondLst>
-                            <p:childTnLst>
-                              <p:par>
-                                <p:cTn id="13" presetID="1" presetClass="entr" presetSubtype="0" fill="hold" grpId="0" nodeType="clickEffect">
-                                  <p:stCondLst>
-                                    <p:cond delay="0"/>
-                                  </p:stCondLst>
-                                  <p:childTnLst>
-                                    <p:set>
-                                      <p:cBhvr>
-                                        <p:cTn id="14" dur="1" fill="hold">
-                                          <p:stCondLst>
-                                            <p:cond delay="0"/>
-                                          </p:stCondLst>
-                                        </p:cTn>
-                                        <p:tgtEl>
-                                          <p:spTgt spid="2">
-                                            <p:txEl>
-                                              <p:pRg st="2" end="2"/>
-                                            </p:txEl>
-                                          </p:spTgt>
-                                        </p:tgtEl>
-                                        <p:attrNameLst>
-                                          <p:attrName>style.visibility</p:attrName>
-                                        </p:attrNameLst>
-                                      </p:cBhvr>
-                                      <p:to>
-                                        <p:strVal val="visible"/>
-                                      </p:to>
-                                    </p:set>
-                                  </p:childTnLst>
-                                </p:cTn>
-                              </p:par>
-                            </p:childTnLst>
-                          </p:cTn>
-                        </p:par>
-                      </p:childTnLst>
-                    </p:cTn>
-                  </p:par>
-                  <p:par>
-                    <p:cTn id="15" fill="hold">
-                      <p:stCondLst>
-                        <p:cond delay="indefinite"/>
-                      </p:stCondLst>
-                      <p:childTnLst>
-                        <p:par>
-                          <p:cTn id="16" fill="hold">
-                            <p:stCondLst>
-                              <p:cond delay="0"/>
-                            </p:stCondLst>
-                            <p:childTnLst>
-                              <p:par>
-                                <p:cTn id="17" presetID="1" presetClass="entr" presetSubtype="0" fill="hold" grpId="0" nodeType="clickEffect">
-                                  <p:stCondLst>
-                                    <p:cond delay="0"/>
-                                  </p:stCondLst>
-                                  <p:childTnLst>
-                                    <p:set>
-                                      <p:cBhvr>
-                                        <p:cTn id="18" dur="1" fill="hold">
-                                          <p:stCondLst>
-                                            <p:cond delay="0"/>
-                                          </p:stCondLst>
-                                        </p:cTn>
-                                        <p:tgtEl>
-                                          <p:spTgt spid="2">
-                                            <p:txEl>
-                                              <p:pRg st="3" end="3"/>
-                                            </p:txEl>
-                                          </p:spTgt>
-                                        </p:tgtEl>
-                                        <p:attrNameLst>
-                                          <p:attrName>style.visibility</p:attrName>
-                                        </p:attrNameLst>
-                                      </p:cBhvr>
-                                      <p:to>
-                                        <p:strVal val="visible"/>
-                                      </p:to>
-                                    </p:set>
-                                  </p:childTnLst>
-                                </p:cTn>
-                              </p:par>
-                            </p:childTnLst>
-                          </p:cTn>
-                        </p:par>
-                      </p:childTnLst>
-                    </p:cTn>
-                  </p:par>
-                  <p:par>
-                    <p:cTn id="19" fill="hold">
-                      <p:stCondLst>
-                        <p:cond delay="indefinite"/>
-                      </p:stCondLst>
-                      <p:childTnLst>
-                        <p:par>
-                          <p:cTn id="20" fill="hold">
-                            <p:stCondLst>
-                              <p:cond delay="0"/>
-                            </p:stCondLst>
-                            <p:childTnLst>
-                              <p:par>
-                                <p:cTn id="21" presetID="1" presetClass="entr" presetSubtype="0" fill="hold" grpId="0" nodeType="clickEffect">
-                                  <p:stCondLst>
-                                    <p:cond delay="0"/>
-                                  </p:stCondLst>
-                                  <p:childTnLst>
-                                    <p:set>
-                                      <p:cBhvr>
-                                        <p:cTn id="22" dur="1" fill="hold">
-                                          <p:stCondLst>
-                                            <p:cond delay="0"/>
-                                          </p:stCondLst>
-                                        </p:cTn>
-                                        <p:tgtEl>
-                                          <p:spTgt spid="2">
-                                            <p:txEl>
-                                              <p:pRg st="4" end="4"/>
-                                            </p:txEl>
-                                          </p:spTgt>
-                                        </p:tgtEl>
-                                        <p:attrNameLst>
-                                          <p:attrName>style.visibility</p:attrName>
-                                        </p:attrNameLst>
-                                      </p:cBhvr>
-                                      <p:to>
-                                        <p:strVal val="visible"/>
-                                      </p:to>
-                                    </p:set>
-                                  </p:childTnLst>
-                                </p:cTn>
-                              </p:par>
-                            </p:childTnLst>
-                          </p:cTn>
-                        </p:par>
-                      </p:childTnLst>
-                    </p:cTn>
-                  </p:par>
-                  <p:par>
-                    <p:cTn id="23" fill="hold">
-                      <p:stCondLst>
-                        <p:cond delay="indefinite"/>
-                      </p:stCondLst>
-                      <p:childTnLst>
-                        <p:par>
-                          <p:cTn id="24" fill="hold">
-                            <p:stCondLst>
-                              <p:cond delay="0"/>
-                            </p:stCondLst>
-                            <p:childTnLst>
-                              <p:par>
-                                <p:cTn id="25" presetID="1" presetClass="entr" presetSubtype="0" fill="hold" grpId="0" nodeType="clickEffect">
-                                  <p:stCondLst>
-                                    <p:cond delay="0"/>
-                                  </p:stCondLst>
-                                  <p:childTnLst>
-                                    <p:set>
-                                      <p:cBhvr>
-                                        <p:cTn id="26" dur="1" fill="hold">
-                                          <p:stCondLst>
-                                            <p:cond delay="0"/>
-                                          </p:stCondLst>
-                                        </p:cTn>
-                                        <p:tgtEl>
-                                          <p:spTgt spid="2">
-                                            <p:txEl>
-                                              <p:pRg st="5" end="5"/>
-                                            </p:txEl>
-                                          </p:spTgt>
-                                        </p:tgtEl>
-                                        <p:attrNameLst>
-                                          <p:attrName>style.visibility</p:attrName>
-                                        </p:attrNameLst>
-                                      </p:cBhvr>
-                                      <p:to>
-                                        <p:strVal val="visible"/>
-                                      </p:to>
-                                    </p:set>
-                                  </p:childTnLst>
-                                </p:cTn>
-                              </p:par>
-                            </p:childTnLst>
-                          </p:cTn>
-                        </p:par>
-                      </p:childTnLst>
-                    </p:cTn>
-                  </p:par>
-                </p:childTnLst>
-              </p:cTn>
-              <p:prevCondLst>
-                <p:cond evt="onPrev" delay="0">
-                  <p:tgtEl>
-                    <p:sldTgt/>
-                  </p:tgtEl>
-                </p:cond>
-              </p:prevCondLst>
-              <p:nextCondLst>
-                <p:cond evt="onNext" delay="0">
-                  <p:tgtEl>
-                    <p:sldTgt/>
-                  </p:tgtEl>
-                </p:cond>
-              </p:nextCondLst>
-            </p:seq>
-          </p:childTnLst>
-        </p:cTn>
-      </p:par>
-    </p:tnLst>
-    <p:bldLst>
-      <p:bldP spid="2" grpId="0" uiExpand="1" build="p"/>
-    </p:bldLst>
-  </p:timing>
-</p:sld>
-</file>
-
-<file path=ppt/slides/slide5.xml><?xml version="1.0" encoding="utf-8"?>
+<file path=ppt/slides/slide11.xml><?xml version="1.0" encoding="utf-8"?>
 <p:sld xmlns:a="http://schemas.openxmlformats.org/drawingml/2006/main" xmlns:r="http://schemas.openxmlformats.org/officeDocument/2006/relationships" xmlns:p="http://schemas.openxmlformats.org/presentationml/2006/main">
   <p:cSld>
     <p:spTree>
@@ -7191,7 +4890,1930 @@
 </p:sld>
 </file>
 
-<file path=ppt/slides/slide6.xml><?xml version="1.0" encoding="utf-8"?>
+<file path=ppt/slides/slide2.xml><?xml version="1.0" encoding="utf-8"?>
+<p:sld xmlns:a="http://schemas.openxmlformats.org/drawingml/2006/main" xmlns:r="http://schemas.openxmlformats.org/officeDocument/2006/relationships" xmlns:p="http://schemas.openxmlformats.org/presentationml/2006/main">
+  <p:cSld>
+    <p:spTree>
+      <p:nvGrpSpPr>
+        <p:cNvPr id="1" name="">
+          <a:extLst>
+            <a:ext uri="{FF2B5EF4-FFF2-40B4-BE49-F238E27FC236}">
+              <a16:creationId xmlns:a16="http://schemas.microsoft.com/office/drawing/2014/main" id="{13318EFD-13D1-118F-A8E4-F9E2D3695A6C}"/>
+            </a:ext>
+          </a:extLst>
+        </p:cNvPr>
+        <p:cNvGrpSpPr/>
+        <p:nvPr/>
+      </p:nvGrpSpPr>
+      <p:grpSpPr>
+        <a:xfrm>
+          <a:off x="0" y="0"/>
+          <a:ext cx="0" cy="0"/>
+          <a:chOff x="0" y="0"/>
+          <a:chExt cx="0" cy="0"/>
+        </a:xfrm>
+      </p:grpSpPr>
+      <p:sp>
+        <p:nvSpPr>
+          <p:cNvPr id="2" name="Text Placeholder 1">
+            <a:extLst>
+              <a:ext uri="{FF2B5EF4-FFF2-40B4-BE49-F238E27FC236}">
+                <a16:creationId xmlns:a16="http://schemas.microsoft.com/office/drawing/2014/main" id="{67726612-73E0-5A94-F635-3A742DD5BA94}"/>
+              </a:ext>
+            </a:extLst>
+          </p:cNvPr>
+          <p:cNvSpPr>
+            <a:spLocks noGrp="1"/>
+          </p:cNvSpPr>
+          <p:nvPr>
+            <p:ph type="body" sz="quarter" idx="13"/>
+          </p:nvPr>
+        </p:nvSpPr>
+        <p:spPr>
+          <a:xfrm>
+            <a:off x="255996" y="1271219"/>
+            <a:ext cx="10624338" cy="4142989"/>
+          </a:xfrm>
+        </p:spPr>
+        <p:txBody>
+          <a:bodyPr/>
+          <a:lstStyle/>
+          <a:p>
+            <a:pPr marL="342900" lvl="0" indent="-342900"/>
+            <a:r>
+              <a:rPr lang="en-IN" sz="2400" dirty="0">
+                <a:latin typeface="+mn-lt"/>
+              </a:rPr>
+              <a:t>Industrial rotating machinery is highly dependent on the reliable operation of rolling-element bearings. </a:t>
+            </a:r>
+          </a:p>
+          <a:p>
+            <a:pPr marL="342900" lvl="0" indent="-342900"/>
+            <a:r>
+              <a:rPr lang="en-IN" sz="2400" dirty="0">
+                <a:latin typeface="+mn-lt"/>
+              </a:rPr>
+              <a:t>Bearing faults can cause unexpected machine downtime, reduced efficiency, increased maintenance costs, and potential equipment failure. </a:t>
+            </a:r>
+          </a:p>
+          <a:p>
+            <a:pPr marL="342900" lvl="0" indent="-342900"/>
+            <a:r>
+              <a:rPr lang="en-IN" sz="2400" dirty="0">
+                <a:latin typeface="+mn-lt"/>
+              </a:rPr>
+              <a:t>Vibration analysis is a widely used technique for detecting and identifying bearing health conditions. </a:t>
+            </a:r>
+          </a:p>
+          <a:p>
+            <a:pPr marL="342900" lvl="0" indent="-342900"/>
+            <a:r>
+              <a:rPr lang="en-IN" sz="2400" dirty="0">
+                <a:latin typeface="+mn-lt"/>
+              </a:rPr>
+              <a:t>Traditional AI-based diagnostic systems may produce probabilistic predictions, making their reasoning difficult to validate and reproduce consistently. </a:t>
+            </a:r>
+          </a:p>
+          <a:p>
+            <a:pPr marL="342900" lvl="0" indent="-342900"/>
+            <a:r>
+              <a:rPr lang="en-IN" sz="2400" dirty="0">
+                <a:latin typeface="+mn-lt"/>
+              </a:rPr>
+              <a:t>This project proposes a Deterministic MCP (Model Context Protocol)-Driven AI Agent for reliable and explainable ball bearing fault diagnosis. </a:t>
+            </a:r>
+          </a:p>
+          <a:p>
+            <a:pPr marL="342900" lvl="0" indent="-342900"/>
+            <a:r>
+              <a:rPr lang="en-IN" sz="2400" dirty="0">
+                <a:latin typeface="+mn-lt"/>
+              </a:rPr>
+              <a:t>The system uses the NASA Bearing Dataset as the primary source of vibration data for developing and evaluating the diagnostic approach.</a:t>
+            </a:r>
+          </a:p>
+          <a:p>
+            <a:pPr marL="0" indent="0">
+              <a:lnSpc>
+                <a:spcPct val="150000"/>
+              </a:lnSpc>
+              <a:buNone/>
+            </a:pPr>
+            <a:endParaRPr lang="en-US" sz="2400" b="0" dirty="0">
+              <a:solidFill>
+                <a:srgbClr val="5583D1"/>
+              </a:solidFill>
+              <a:latin typeface="+mn-lt"/>
+            </a:endParaRPr>
+          </a:p>
+        </p:txBody>
+      </p:sp>
+      <p:sp>
+        <p:nvSpPr>
+          <p:cNvPr id="3" name="TextBox 2">
+            <a:extLst>
+              <a:ext uri="{FF2B5EF4-FFF2-40B4-BE49-F238E27FC236}">
+                <a16:creationId xmlns:a16="http://schemas.microsoft.com/office/drawing/2014/main" id="{AB4E3812-AF2F-9DD8-6ECF-C3425146B38F}"/>
+              </a:ext>
+            </a:extLst>
+          </p:cNvPr>
+          <p:cNvSpPr txBox="1"/>
+          <p:nvPr/>
+        </p:nvSpPr>
+        <p:spPr>
+          <a:xfrm>
+            <a:off x="255996" y="502545"/>
+            <a:ext cx="10624338" cy="646331"/>
+          </a:xfrm>
+          <a:prstGeom prst="rect">
+            <a:avLst/>
+          </a:prstGeom>
+          <a:noFill/>
+        </p:spPr>
+        <p:txBody>
+          <a:bodyPr wrap="square" rtlCol="0">
+            <a:spAutoFit/>
+          </a:bodyPr>
+          <a:lstStyle/>
+          <a:p>
+            <a:pPr marL="0" marR="0" lvl="0" indent="0" algn="l" defTabSz="914400" rtl="0" eaLnBrk="1" fontAlgn="auto" latinLnBrk="0" hangingPunct="1">
+              <a:lnSpc>
+                <a:spcPct val="100000"/>
+              </a:lnSpc>
+              <a:spcBef>
+                <a:spcPts val="0"/>
+              </a:spcBef>
+              <a:spcAft>
+                <a:spcPts val="0"/>
+              </a:spcAft>
+              <a:buClrTx/>
+              <a:buSzTx/>
+              <a:buFontTx/>
+              <a:buNone/>
+              <a:tabLst/>
+              <a:defRPr/>
+            </a:pPr>
+            <a:r>
+              <a:rPr kumimoji="0" lang="en-US" sz="3600" b="1" i="0" u="none" strike="noStrike" kern="1200" cap="none" spc="0" normalizeH="0" baseline="0" noProof="0" dirty="0">
+                <a:ln>
+                  <a:noFill/>
+                </a:ln>
+                <a:solidFill>
+                  <a:srgbClr val="5B9BD5">
+                    <a:lumMod val="50000"/>
+                  </a:srgbClr>
+                </a:solidFill>
+                <a:effectLst/>
+                <a:uLnTx/>
+                <a:uFillTx/>
+                <a:latin typeface="Calibri" panose="020F0502020204030204"/>
+                <a:ea typeface="+mn-ea"/>
+                <a:cs typeface="+mn-cs"/>
+              </a:rPr>
+              <a:t>Introduction</a:t>
+            </a:r>
+          </a:p>
+        </p:txBody>
+      </p:sp>
+      <p:cxnSp>
+        <p:nvCxnSpPr>
+          <p:cNvPr id="5" name="Straight Connector 4">
+            <a:extLst>
+              <a:ext uri="{FF2B5EF4-FFF2-40B4-BE49-F238E27FC236}">
+                <a16:creationId xmlns:a16="http://schemas.microsoft.com/office/drawing/2014/main" id="{A295426A-3395-FE92-30C7-C8A6AC62DE62}"/>
+              </a:ext>
+            </a:extLst>
+          </p:cNvPr>
+          <p:cNvCxnSpPr>
+            <a:cxnSpLocks/>
+          </p:cNvCxnSpPr>
+          <p:nvPr/>
+        </p:nvCxnSpPr>
+        <p:spPr>
+          <a:xfrm>
+            <a:off x="221274" y="1191756"/>
+            <a:ext cx="7305799" cy="0"/>
+          </a:xfrm>
+          <a:prstGeom prst="line">
+            <a:avLst/>
+          </a:prstGeom>
+          <a:ln w="28575">
+            <a:solidFill>
+              <a:schemeClr val="accent6"/>
+            </a:solidFill>
+          </a:ln>
+        </p:spPr>
+        <p:style>
+          <a:lnRef idx="1">
+            <a:schemeClr val="accent1"/>
+          </a:lnRef>
+          <a:fillRef idx="0">
+            <a:schemeClr val="accent1"/>
+          </a:fillRef>
+          <a:effectRef idx="0">
+            <a:schemeClr val="accent1"/>
+          </a:effectRef>
+          <a:fontRef idx="minor">
+            <a:schemeClr val="tx1"/>
+          </a:fontRef>
+        </p:style>
+      </p:cxnSp>
+      <p:sp>
+        <p:nvSpPr>
+          <p:cNvPr id="4" name="TextBox 3">
+            <a:extLst>
+              <a:ext uri="{FF2B5EF4-FFF2-40B4-BE49-F238E27FC236}">
+                <a16:creationId xmlns:a16="http://schemas.microsoft.com/office/drawing/2014/main" id="{2D91B1D4-191E-E882-BD37-9FBAED57B57F}"/>
+              </a:ext>
+            </a:extLst>
+          </p:cNvPr>
+          <p:cNvSpPr txBox="1"/>
+          <p:nvPr/>
+        </p:nvSpPr>
+        <p:spPr>
+          <a:xfrm>
+            <a:off x="4735287" y="57036"/>
+            <a:ext cx="7456714" cy="369332"/>
+          </a:xfrm>
+          <a:prstGeom prst="rect">
+            <a:avLst/>
+          </a:prstGeom>
+          <a:noFill/>
+        </p:spPr>
+        <p:txBody>
+          <a:bodyPr wrap="square" rtlCol="0">
+            <a:spAutoFit/>
+          </a:bodyPr>
+          <a:lstStyle/>
+          <a:p>
+            <a:pPr lvl="0" algn="ctr">
+              <a:defRPr/>
+            </a:pPr>
+            <a:r>
+              <a:rPr lang="en-GB" b="1" dirty="0">
+                <a:solidFill>
+                  <a:prstClr val="white"/>
+                </a:solidFill>
+                <a:cs typeface="Calibri" panose="020F0502020204030204" pitchFamily="34" charset="0"/>
+              </a:rPr>
+              <a:t>Deterministic MCP-Driven AI Agents for Ball Bearing Vibration Diagnostics</a:t>
+            </a:r>
+            <a:endParaRPr lang="en-US" b="1" dirty="0">
+              <a:solidFill>
+                <a:prstClr val="white"/>
+              </a:solidFill>
+              <a:cs typeface="Calibri" panose="020F0502020204030204" pitchFamily="34" charset="0"/>
+            </a:endParaRPr>
+          </a:p>
+        </p:txBody>
+      </p:sp>
+    </p:spTree>
+    <p:extLst>
+      <p:ext uri="{BB962C8B-B14F-4D97-AF65-F5344CB8AC3E}">
+        <p14:creationId xmlns:p14="http://schemas.microsoft.com/office/powerpoint/2010/main" val="2088180620"/>
+      </p:ext>
+    </p:extLst>
+  </p:cSld>
+  <p:clrMapOvr>
+    <a:masterClrMapping/>
+  </p:clrMapOvr>
+  <mc:AlternateContent xmlns:mc="http://schemas.openxmlformats.org/markup-compatibility/2006" xmlns:p14="http://schemas.microsoft.com/office/powerpoint/2010/main">
+    <mc:Choice Requires="p14">
+      <p:transition spd="med" p14:dur="700">
+        <p:fade/>
+      </p:transition>
+    </mc:Choice>
+    <mc:Fallback xmlns="">
+      <p:transition spd="med">
+        <p:fade/>
+      </p:transition>
+    </mc:Fallback>
+  </mc:AlternateContent>
+  <p:timing>
+    <p:tnLst>
+      <p:par>
+        <p:cTn id="1" dur="indefinite" restart="never" nodeType="tmRoot">
+          <p:childTnLst>
+            <p:seq concurrent="1" nextAc="seek">
+              <p:cTn id="2" dur="indefinite" nodeType="mainSeq">
+                <p:childTnLst>
+                  <p:par>
+                    <p:cTn id="3" fill="hold">
+                      <p:stCondLst>
+                        <p:cond delay="indefinite"/>
+                      </p:stCondLst>
+                      <p:childTnLst>
+                        <p:par>
+                          <p:cTn id="4" fill="hold">
+                            <p:stCondLst>
+                              <p:cond delay="0"/>
+                            </p:stCondLst>
+                            <p:childTnLst>
+                              <p:par>
+                                <p:cTn id="5" presetID="1" presetClass="entr" presetSubtype="0" fill="hold" grpId="0" nodeType="clickEffect">
+                                  <p:stCondLst>
+                                    <p:cond delay="0"/>
+                                  </p:stCondLst>
+                                  <p:childTnLst>
+                                    <p:set>
+                                      <p:cBhvr>
+                                        <p:cTn id="6" dur="1" fill="hold">
+                                          <p:stCondLst>
+                                            <p:cond delay="0"/>
+                                          </p:stCondLst>
+                                        </p:cTn>
+                                        <p:tgtEl>
+                                          <p:spTgt spid="2">
+                                            <p:txEl>
+                                              <p:pRg st="0" end="0"/>
+                                            </p:txEl>
+                                          </p:spTgt>
+                                        </p:tgtEl>
+                                        <p:attrNameLst>
+                                          <p:attrName>style.visibility</p:attrName>
+                                        </p:attrNameLst>
+                                      </p:cBhvr>
+                                      <p:to>
+                                        <p:strVal val="visible"/>
+                                      </p:to>
+                                    </p:set>
+                                  </p:childTnLst>
+                                </p:cTn>
+                              </p:par>
+                            </p:childTnLst>
+                          </p:cTn>
+                        </p:par>
+                      </p:childTnLst>
+                    </p:cTn>
+                  </p:par>
+                  <p:par>
+                    <p:cTn id="7" fill="hold">
+                      <p:stCondLst>
+                        <p:cond delay="indefinite"/>
+                      </p:stCondLst>
+                      <p:childTnLst>
+                        <p:par>
+                          <p:cTn id="8" fill="hold">
+                            <p:stCondLst>
+                              <p:cond delay="0"/>
+                            </p:stCondLst>
+                            <p:childTnLst>
+                              <p:par>
+                                <p:cTn id="9" presetID="1" presetClass="entr" presetSubtype="0" fill="hold" grpId="0" nodeType="clickEffect">
+                                  <p:stCondLst>
+                                    <p:cond delay="0"/>
+                                  </p:stCondLst>
+                                  <p:childTnLst>
+                                    <p:set>
+                                      <p:cBhvr>
+                                        <p:cTn id="10" dur="1" fill="hold">
+                                          <p:stCondLst>
+                                            <p:cond delay="0"/>
+                                          </p:stCondLst>
+                                        </p:cTn>
+                                        <p:tgtEl>
+                                          <p:spTgt spid="2">
+                                            <p:txEl>
+                                              <p:pRg st="1" end="1"/>
+                                            </p:txEl>
+                                          </p:spTgt>
+                                        </p:tgtEl>
+                                        <p:attrNameLst>
+                                          <p:attrName>style.visibility</p:attrName>
+                                        </p:attrNameLst>
+                                      </p:cBhvr>
+                                      <p:to>
+                                        <p:strVal val="visible"/>
+                                      </p:to>
+                                    </p:set>
+                                  </p:childTnLst>
+                                </p:cTn>
+                              </p:par>
+                            </p:childTnLst>
+                          </p:cTn>
+                        </p:par>
+                      </p:childTnLst>
+                    </p:cTn>
+                  </p:par>
+                  <p:par>
+                    <p:cTn id="11" fill="hold">
+                      <p:stCondLst>
+                        <p:cond delay="indefinite"/>
+                      </p:stCondLst>
+                      <p:childTnLst>
+                        <p:par>
+                          <p:cTn id="12" fill="hold">
+                            <p:stCondLst>
+                              <p:cond delay="0"/>
+                            </p:stCondLst>
+                            <p:childTnLst>
+                              <p:par>
+                                <p:cTn id="13" presetID="1" presetClass="entr" presetSubtype="0" fill="hold" grpId="0" nodeType="clickEffect">
+                                  <p:stCondLst>
+                                    <p:cond delay="0"/>
+                                  </p:stCondLst>
+                                  <p:childTnLst>
+                                    <p:set>
+                                      <p:cBhvr>
+                                        <p:cTn id="14" dur="1" fill="hold">
+                                          <p:stCondLst>
+                                            <p:cond delay="0"/>
+                                          </p:stCondLst>
+                                        </p:cTn>
+                                        <p:tgtEl>
+                                          <p:spTgt spid="2">
+                                            <p:txEl>
+                                              <p:pRg st="2" end="2"/>
+                                            </p:txEl>
+                                          </p:spTgt>
+                                        </p:tgtEl>
+                                        <p:attrNameLst>
+                                          <p:attrName>style.visibility</p:attrName>
+                                        </p:attrNameLst>
+                                      </p:cBhvr>
+                                      <p:to>
+                                        <p:strVal val="visible"/>
+                                      </p:to>
+                                    </p:set>
+                                  </p:childTnLst>
+                                </p:cTn>
+                              </p:par>
+                            </p:childTnLst>
+                          </p:cTn>
+                        </p:par>
+                      </p:childTnLst>
+                    </p:cTn>
+                  </p:par>
+                  <p:par>
+                    <p:cTn id="15" fill="hold">
+                      <p:stCondLst>
+                        <p:cond delay="indefinite"/>
+                      </p:stCondLst>
+                      <p:childTnLst>
+                        <p:par>
+                          <p:cTn id="16" fill="hold">
+                            <p:stCondLst>
+                              <p:cond delay="0"/>
+                            </p:stCondLst>
+                            <p:childTnLst>
+                              <p:par>
+                                <p:cTn id="17" presetID="1" presetClass="entr" presetSubtype="0" fill="hold" grpId="0" nodeType="clickEffect">
+                                  <p:stCondLst>
+                                    <p:cond delay="0"/>
+                                  </p:stCondLst>
+                                  <p:childTnLst>
+                                    <p:set>
+                                      <p:cBhvr>
+                                        <p:cTn id="18" dur="1" fill="hold">
+                                          <p:stCondLst>
+                                            <p:cond delay="0"/>
+                                          </p:stCondLst>
+                                        </p:cTn>
+                                        <p:tgtEl>
+                                          <p:spTgt spid="2">
+                                            <p:txEl>
+                                              <p:pRg st="3" end="3"/>
+                                            </p:txEl>
+                                          </p:spTgt>
+                                        </p:tgtEl>
+                                        <p:attrNameLst>
+                                          <p:attrName>style.visibility</p:attrName>
+                                        </p:attrNameLst>
+                                      </p:cBhvr>
+                                      <p:to>
+                                        <p:strVal val="visible"/>
+                                      </p:to>
+                                    </p:set>
+                                  </p:childTnLst>
+                                </p:cTn>
+                              </p:par>
+                            </p:childTnLst>
+                          </p:cTn>
+                        </p:par>
+                      </p:childTnLst>
+                    </p:cTn>
+                  </p:par>
+                  <p:par>
+                    <p:cTn id="19" fill="hold">
+                      <p:stCondLst>
+                        <p:cond delay="indefinite"/>
+                      </p:stCondLst>
+                      <p:childTnLst>
+                        <p:par>
+                          <p:cTn id="20" fill="hold">
+                            <p:stCondLst>
+                              <p:cond delay="0"/>
+                            </p:stCondLst>
+                            <p:childTnLst>
+                              <p:par>
+                                <p:cTn id="21" presetID="1" presetClass="entr" presetSubtype="0" fill="hold" grpId="0" nodeType="clickEffect">
+                                  <p:stCondLst>
+                                    <p:cond delay="0"/>
+                                  </p:stCondLst>
+                                  <p:childTnLst>
+                                    <p:set>
+                                      <p:cBhvr>
+                                        <p:cTn id="22" dur="1" fill="hold">
+                                          <p:stCondLst>
+                                            <p:cond delay="0"/>
+                                          </p:stCondLst>
+                                        </p:cTn>
+                                        <p:tgtEl>
+                                          <p:spTgt spid="2">
+                                            <p:txEl>
+                                              <p:pRg st="4" end="4"/>
+                                            </p:txEl>
+                                          </p:spTgt>
+                                        </p:tgtEl>
+                                        <p:attrNameLst>
+                                          <p:attrName>style.visibility</p:attrName>
+                                        </p:attrNameLst>
+                                      </p:cBhvr>
+                                      <p:to>
+                                        <p:strVal val="visible"/>
+                                      </p:to>
+                                    </p:set>
+                                  </p:childTnLst>
+                                </p:cTn>
+                              </p:par>
+                            </p:childTnLst>
+                          </p:cTn>
+                        </p:par>
+                      </p:childTnLst>
+                    </p:cTn>
+                  </p:par>
+                  <p:par>
+                    <p:cTn id="23" fill="hold">
+                      <p:stCondLst>
+                        <p:cond delay="indefinite"/>
+                      </p:stCondLst>
+                      <p:childTnLst>
+                        <p:par>
+                          <p:cTn id="24" fill="hold">
+                            <p:stCondLst>
+                              <p:cond delay="0"/>
+                            </p:stCondLst>
+                            <p:childTnLst>
+                              <p:par>
+                                <p:cTn id="25" presetID="1" presetClass="entr" presetSubtype="0" fill="hold" grpId="0" nodeType="clickEffect">
+                                  <p:stCondLst>
+                                    <p:cond delay="0"/>
+                                  </p:stCondLst>
+                                  <p:childTnLst>
+                                    <p:set>
+                                      <p:cBhvr>
+                                        <p:cTn id="26" dur="1" fill="hold">
+                                          <p:stCondLst>
+                                            <p:cond delay="0"/>
+                                          </p:stCondLst>
+                                        </p:cTn>
+                                        <p:tgtEl>
+                                          <p:spTgt spid="2">
+                                            <p:txEl>
+                                              <p:pRg st="5" end="5"/>
+                                            </p:txEl>
+                                          </p:spTgt>
+                                        </p:tgtEl>
+                                        <p:attrNameLst>
+                                          <p:attrName>style.visibility</p:attrName>
+                                        </p:attrNameLst>
+                                      </p:cBhvr>
+                                      <p:to>
+                                        <p:strVal val="visible"/>
+                                      </p:to>
+                                    </p:set>
+                                  </p:childTnLst>
+                                </p:cTn>
+                              </p:par>
+                            </p:childTnLst>
+                          </p:cTn>
+                        </p:par>
+                      </p:childTnLst>
+                    </p:cTn>
+                  </p:par>
+                </p:childTnLst>
+              </p:cTn>
+              <p:prevCondLst>
+                <p:cond evt="onPrev" delay="0">
+                  <p:tgtEl>
+                    <p:sldTgt/>
+                  </p:tgtEl>
+                </p:cond>
+              </p:prevCondLst>
+              <p:nextCondLst>
+                <p:cond evt="onNext" delay="0">
+                  <p:tgtEl>
+                    <p:sldTgt/>
+                  </p:tgtEl>
+                </p:cond>
+              </p:nextCondLst>
+            </p:seq>
+          </p:childTnLst>
+        </p:cTn>
+      </p:par>
+    </p:tnLst>
+    <p:bldLst>
+      <p:bldP spid="2" grpId="0" uiExpand="1" build="p"/>
+    </p:bldLst>
+  </p:timing>
+</p:sld>
+</file>
+
+<file path=ppt/slides/slide3.xml><?xml version="1.0" encoding="utf-8"?>
+<p:sld xmlns:a="http://schemas.openxmlformats.org/drawingml/2006/main" xmlns:r="http://schemas.openxmlformats.org/officeDocument/2006/relationships" xmlns:p="http://schemas.openxmlformats.org/presentationml/2006/main">
+  <p:cSld>
+    <p:spTree>
+      <p:nvGrpSpPr>
+        <p:cNvPr id="1" name="">
+          <a:extLst>
+            <a:ext uri="{FF2B5EF4-FFF2-40B4-BE49-F238E27FC236}">
+              <a16:creationId xmlns:a16="http://schemas.microsoft.com/office/drawing/2014/main" id="{86D1235D-73A1-0B84-0745-6B97432CB074}"/>
+            </a:ext>
+          </a:extLst>
+        </p:cNvPr>
+        <p:cNvGrpSpPr/>
+        <p:nvPr/>
+      </p:nvGrpSpPr>
+      <p:grpSpPr>
+        <a:xfrm>
+          <a:off x="0" y="0"/>
+          <a:ext cx="0" cy="0"/>
+          <a:chOff x="0" y="0"/>
+          <a:chExt cx="0" cy="0"/>
+        </a:xfrm>
+      </p:grpSpPr>
+      <p:sp>
+        <p:nvSpPr>
+          <p:cNvPr id="2" name="Text Placeholder 1">
+            <a:extLst>
+              <a:ext uri="{FF2B5EF4-FFF2-40B4-BE49-F238E27FC236}">
+                <a16:creationId xmlns:a16="http://schemas.microsoft.com/office/drawing/2014/main" id="{44D551BF-43EB-C049-6D3B-4D17D5775294}"/>
+              </a:ext>
+            </a:extLst>
+          </p:cNvPr>
+          <p:cNvSpPr>
+            <a:spLocks noGrp="1"/>
+          </p:cNvSpPr>
+          <p:nvPr>
+            <p:ph type="body" sz="quarter" idx="13"/>
+          </p:nvPr>
+        </p:nvSpPr>
+        <p:spPr>
+          <a:xfrm>
+            <a:off x="255996" y="1271219"/>
+            <a:ext cx="10624338" cy="4142989"/>
+          </a:xfrm>
+        </p:spPr>
+        <p:txBody>
+          <a:bodyPr/>
+          <a:lstStyle/>
+          <a:p>
+            <a:pPr marL="342900" lvl="0" indent="-342900"/>
+            <a:r>
+              <a:rPr lang="en-IN" sz="2400" dirty="0">
+                <a:latin typeface="+mn-lt"/>
+              </a:rPr>
+              <a:t>To develop a Deterministic MCP-Driven AI Agent for ball bearing health monitoring and fault diagnosis. </a:t>
+            </a:r>
+          </a:p>
+          <a:p>
+            <a:pPr marL="342900" lvl="0" indent="-342900"/>
+            <a:r>
+              <a:rPr lang="en-IN" sz="2400" dirty="0">
+                <a:latin typeface="+mn-lt"/>
+              </a:rPr>
+              <a:t>To </a:t>
+            </a:r>
+            <a:r>
+              <a:rPr lang="en-IN" sz="2400" dirty="0" err="1">
+                <a:latin typeface="+mn-lt"/>
+              </a:rPr>
+              <a:t>analyze</a:t>
+            </a:r>
+            <a:r>
+              <a:rPr lang="en-IN" sz="2400" dirty="0">
+                <a:latin typeface="+mn-lt"/>
+              </a:rPr>
+              <a:t> vibration signals and accurately identify different bearing health conditions. </a:t>
+            </a:r>
+          </a:p>
+          <a:p>
+            <a:pPr marL="342900" lvl="0" indent="-342900"/>
+            <a:r>
+              <a:rPr lang="en-IN" sz="2400" dirty="0">
+                <a:latin typeface="+mn-lt"/>
+              </a:rPr>
+              <a:t>To incorporate ISO-based standards and diagnostic principles into the analysis workflow. </a:t>
+            </a:r>
+          </a:p>
+          <a:p>
+            <a:pPr marL="342900" lvl="0" indent="-342900"/>
+            <a:r>
+              <a:rPr lang="en-IN" sz="2400" dirty="0">
+                <a:latin typeface="+mn-lt"/>
+              </a:rPr>
+              <a:t>To provide consistent, explainable, and reproducible fault identification rather than relying solely on probabilistic outputs. </a:t>
+            </a:r>
+          </a:p>
+          <a:p>
+            <a:pPr marL="342900" lvl="0" indent="-342900"/>
+            <a:r>
+              <a:rPr lang="en-IN" sz="2400" dirty="0">
+                <a:latin typeface="+mn-lt"/>
+              </a:rPr>
+              <a:t>To assist maintenance engineers and reliability teams in making informed maintenance decisions. </a:t>
+            </a:r>
+          </a:p>
+          <a:p>
+            <a:pPr marL="342900" lvl="0" indent="-342900"/>
+            <a:r>
+              <a:rPr lang="en-IN" sz="2400" dirty="0">
+                <a:latin typeface="+mn-lt"/>
+              </a:rPr>
+              <a:t>To reduce the risk of unplanned equipment failures, downtime, and unnecessary maintenance.</a:t>
+            </a:r>
+          </a:p>
+          <a:p>
+            <a:pPr marL="0" indent="0">
+              <a:lnSpc>
+                <a:spcPct val="150000"/>
+              </a:lnSpc>
+              <a:buNone/>
+            </a:pPr>
+            <a:endParaRPr lang="en-US" sz="2400" b="0" dirty="0">
+              <a:solidFill>
+                <a:srgbClr val="5583D1"/>
+              </a:solidFill>
+              <a:latin typeface="+mn-lt"/>
+            </a:endParaRPr>
+          </a:p>
+        </p:txBody>
+      </p:sp>
+      <p:sp>
+        <p:nvSpPr>
+          <p:cNvPr id="3" name="TextBox 2">
+            <a:extLst>
+              <a:ext uri="{FF2B5EF4-FFF2-40B4-BE49-F238E27FC236}">
+                <a16:creationId xmlns:a16="http://schemas.microsoft.com/office/drawing/2014/main" id="{72FF40D3-B05A-88C3-591F-882A93FC9918}"/>
+              </a:ext>
+            </a:extLst>
+          </p:cNvPr>
+          <p:cNvSpPr txBox="1"/>
+          <p:nvPr/>
+        </p:nvSpPr>
+        <p:spPr>
+          <a:xfrm>
+            <a:off x="255996" y="502545"/>
+            <a:ext cx="10624338" cy="646331"/>
+          </a:xfrm>
+          <a:prstGeom prst="rect">
+            <a:avLst/>
+          </a:prstGeom>
+          <a:noFill/>
+        </p:spPr>
+        <p:txBody>
+          <a:bodyPr wrap="square" rtlCol="0">
+            <a:spAutoFit/>
+          </a:bodyPr>
+          <a:lstStyle/>
+          <a:p>
+            <a:pPr marL="0" marR="0" lvl="0" indent="0" algn="l" defTabSz="914400" rtl="0" eaLnBrk="1" fontAlgn="auto" latinLnBrk="0" hangingPunct="1">
+              <a:lnSpc>
+                <a:spcPct val="100000"/>
+              </a:lnSpc>
+              <a:spcBef>
+                <a:spcPts val="0"/>
+              </a:spcBef>
+              <a:spcAft>
+                <a:spcPts val="0"/>
+              </a:spcAft>
+              <a:buClrTx/>
+              <a:buSzTx/>
+              <a:buFontTx/>
+              <a:buNone/>
+              <a:tabLst/>
+              <a:defRPr/>
+            </a:pPr>
+            <a:r>
+              <a:rPr kumimoji="0" lang="en-US" sz="3600" b="1" i="0" u="none" strike="noStrike" kern="1200" cap="none" spc="0" normalizeH="0" baseline="0" noProof="0" dirty="0">
+                <a:ln>
+                  <a:noFill/>
+                </a:ln>
+                <a:solidFill>
+                  <a:srgbClr val="5B9BD5">
+                    <a:lumMod val="50000"/>
+                  </a:srgbClr>
+                </a:solidFill>
+                <a:effectLst/>
+                <a:uLnTx/>
+                <a:uFillTx/>
+                <a:latin typeface="Calibri" panose="020F0502020204030204"/>
+                <a:ea typeface="+mn-ea"/>
+                <a:cs typeface="+mn-cs"/>
+              </a:rPr>
+              <a:t>Objective</a:t>
+            </a:r>
+          </a:p>
+        </p:txBody>
+      </p:sp>
+      <p:cxnSp>
+        <p:nvCxnSpPr>
+          <p:cNvPr id="5" name="Straight Connector 4">
+            <a:extLst>
+              <a:ext uri="{FF2B5EF4-FFF2-40B4-BE49-F238E27FC236}">
+                <a16:creationId xmlns:a16="http://schemas.microsoft.com/office/drawing/2014/main" id="{12740D4D-2363-70E1-0E6E-1BDDA8C33C87}"/>
+              </a:ext>
+            </a:extLst>
+          </p:cNvPr>
+          <p:cNvCxnSpPr>
+            <a:cxnSpLocks/>
+          </p:cNvCxnSpPr>
+          <p:nvPr/>
+        </p:nvCxnSpPr>
+        <p:spPr>
+          <a:xfrm>
+            <a:off x="221274" y="1191756"/>
+            <a:ext cx="7305799" cy="0"/>
+          </a:xfrm>
+          <a:prstGeom prst="line">
+            <a:avLst/>
+          </a:prstGeom>
+          <a:ln w="28575">
+            <a:solidFill>
+              <a:schemeClr val="accent6"/>
+            </a:solidFill>
+          </a:ln>
+        </p:spPr>
+        <p:style>
+          <a:lnRef idx="1">
+            <a:schemeClr val="accent1"/>
+          </a:lnRef>
+          <a:fillRef idx="0">
+            <a:schemeClr val="accent1"/>
+          </a:fillRef>
+          <a:effectRef idx="0">
+            <a:schemeClr val="accent1"/>
+          </a:effectRef>
+          <a:fontRef idx="minor">
+            <a:schemeClr val="tx1"/>
+          </a:fontRef>
+        </p:style>
+      </p:cxnSp>
+      <p:sp>
+        <p:nvSpPr>
+          <p:cNvPr id="4" name="TextBox 3">
+            <a:extLst>
+              <a:ext uri="{FF2B5EF4-FFF2-40B4-BE49-F238E27FC236}">
+                <a16:creationId xmlns:a16="http://schemas.microsoft.com/office/drawing/2014/main" id="{E4452DD5-D934-4955-F39B-2109AC72692F}"/>
+              </a:ext>
+            </a:extLst>
+          </p:cNvPr>
+          <p:cNvSpPr txBox="1"/>
+          <p:nvPr/>
+        </p:nvSpPr>
+        <p:spPr>
+          <a:xfrm>
+            <a:off x="4931229" y="57036"/>
+            <a:ext cx="7260771" cy="369332"/>
+          </a:xfrm>
+          <a:prstGeom prst="rect">
+            <a:avLst/>
+          </a:prstGeom>
+          <a:noFill/>
+        </p:spPr>
+        <p:txBody>
+          <a:bodyPr wrap="square" rtlCol="0">
+            <a:spAutoFit/>
+          </a:bodyPr>
+          <a:lstStyle/>
+          <a:p>
+            <a:pPr lvl="0" algn="ctr">
+              <a:defRPr/>
+            </a:pPr>
+            <a:r>
+              <a:rPr lang="en-GB" b="1" dirty="0">
+                <a:solidFill>
+                  <a:prstClr val="white"/>
+                </a:solidFill>
+                <a:cs typeface="Calibri" panose="020F0502020204030204" pitchFamily="34" charset="0"/>
+              </a:rPr>
+              <a:t>Deterministic MCP-Driven AI Agents for Ball Bearing Vibration Diagnostics</a:t>
+            </a:r>
+            <a:endParaRPr lang="en-US" b="1" dirty="0">
+              <a:solidFill>
+                <a:prstClr val="white"/>
+              </a:solidFill>
+              <a:cs typeface="Calibri" panose="020F0502020204030204" pitchFamily="34" charset="0"/>
+            </a:endParaRPr>
+          </a:p>
+        </p:txBody>
+      </p:sp>
+    </p:spTree>
+    <p:extLst>
+      <p:ext uri="{BB962C8B-B14F-4D97-AF65-F5344CB8AC3E}">
+        <p14:creationId xmlns:p14="http://schemas.microsoft.com/office/powerpoint/2010/main" val="1739450533"/>
+      </p:ext>
+    </p:extLst>
+  </p:cSld>
+  <p:clrMapOvr>
+    <a:masterClrMapping/>
+  </p:clrMapOvr>
+  <mc:AlternateContent xmlns:mc="http://schemas.openxmlformats.org/markup-compatibility/2006" xmlns:p14="http://schemas.microsoft.com/office/powerpoint/2010/main">
+    <mc:Choice Requires="p14">
+      <p:transition spd="med" p14:dur="700">
+        <p:fade/>
+      </p:transition>
+    </mc:Choice>
+    <mc:Fallback xmlns="">
+      <p:transition spd="med">
+        <p:fade/>
+      </p:transition>
+    </mc:Fallback>
+  </mc:AlternateContent>
+  <p:timing>
+    <p:tnLst>
+      <p:par>
+        <p:cTn id="1" dur="indefinite" restart="never" nodeType="tmRoot">
+          <p:childTnLst>
+            <p:seq concurrent="1" nextAc="seek">
+              <p:cTn id="2" dur="indefinite" nodeType="mainSeq">
+                <p:childTnLst>
+                  <p:par>
+                    <p:cTn id="3" fill="hold">
+                      <p:stCondLst>
+                        <p:cond delay="indefinite"/>
+                      </p:stCondLst>
+                      <p:childTnLst>
+                        <p:par>
+                          <p:cTn id="4" fill="hold">
+                            <p:stCondLst>
+                              <p:cond delay="0"/>
+                            </p:stCondLst>
+                            <p:childTnLst>
+                              <p:par>
+                                <p:cTn id="5" presetID="1" presetClass="entr" presetSubtype="0" fill="hold" grpId="0" nodeType="clickEffect">
+                                  <p:stCondLst>
+                                    <p:cond delay="0"/>
+                                  </p:stCondLst>
+                                  <p:childTnLst>
+                                    <p:set>
+                                      <p:cBhvr>
+                                        <p:cTn id="6" dur="1" fill="hold">
+                                          <p:stCondLst>
+                                            <p:cond delay="0"/>
+                                          </p:stCondLst>
+                                        </p:cTn>
+                                        <p:tgtEl>
+                                          <p:spTgt spid="2">
+                                            <p:txEl>
+                                              <p:pRg st="0" end="0"/>
+                                            </p:txEl>
+                                          </p:spTgt>
+                                        </p:tgtEl>
+                                        <p:attrNameLst>
+                                          <p:attrName>style.visibility</p:attrName>
+                                        </p:attrNameLst>
+                                      </p:cBhvr>
+                                      <p:to>
+                                        <p:strVal val="visible"/>
+                                      </p:to>
+                                    </p:set>
+                                  </p:childTnLst>
+                                </p:cTn>
+                              </p:par>
+                            </p:childTnLst>
+                          </p:cTn>
+                        </p:par>
+                      </p:childTnLst>
+                    </p:cTn>
+                  </p:par>
+                  <p:par>
+                    <p:cTn id="7" fill="hold">
+                      <p:stCondLst>
+                        <p:cond delay="indefinite"/>
+                      </p:stCondLst>
+                      <p:childTnLst>
+                        <p:par>
+                          <p:cTn id="8" fill="hold">
+                            <p:stCondLst>
+                              <p:cond delay="0"/>
+                            </p:stCondLst>
+                            <p:childTnLst>
+                              <p:par>
+                                <p:cTn id="9" presetID="1" presetClass="entr" presetSubtype="0" fill="hold" grpId="0" nodeType="clickEffect">
+                                  <p:stCondLst>
+                                    <p:cond delay="0"/>
+                                  </p:stCondLst>
+                                  <p:childTnLst>
+                                    <p:set>
+                                      <p:cBhvr>
+                                        <p:cTn id="10" dur="1" fill="hold">
+                                          <p:stCondLst>
+                                            <p:cond delay="0"/>
+                                          </p:stCondLst>
+                                        </p:cTn>
+                                        <p:tgtEl>
+                                          <p:spTgt spid="2">
+                                            <p:txEl>
+                                              <p:pRg st="1" end="1"/>
+                                            </p:txEl>
+                                          </p:spTgt>
+                                        </p:tgtEl>
+                                        <p:attrNameLst>
+                                          <p:attrName>style.visibility</p:attrName>
+                                        </p:attrNameLst>
+                                      </p:cBhvr>
+                                      <p:to>
+                                        <p:strVal val="visible"/>
+                                      </p:to>
+                                    </p:set>
+                                  </p:childTnLst>
+                                </p:cTn>
+                              </p:par>
+                            </p:childTnLst>
+                          </p:cTn>
+                        </p:par>
+                      </p:childTnLst>
+                    </p:cTn>
+                  </p:par>
+                  <p:par>
+                    <p:cTn id="11" fill="hold">
+                      <p:stCondLst>
+                        <p:cond delay="indefinite"/>
+                      </p:stCondLst>
+                      <p:childTnLst>
+                        <p:par>
+                          <p:cTn id="12" fill="hold">
+                            <p:stCondLst>
+                              <p:cond delay="0"/>
+                            </p:stCondLst>
+                            <p:childTnLst>
+                              <p:par>
+                                <p:cTn id="13" presetID="1" presetClass="entr" presetSubtype="0" fill="hold" grpId="0" nodeType="clickEffect">
+                                  <p:stCondLst>
+                                    <p:cond delay="0"/>
+                                  </p:stCondLst>
+                                  <p:childTnLst>
+                                    <p:set>
+                                      <p:cBhvr>
+                                        <p:cTn id="14" dur="1" fill="hold">
+                                          <p:stCondLst>
+                                            <p:cond delay="0"/>
+                                          </p:stCondLst>
+                                        </p:cTn>
+                                        <p:tgtEl>
+                                          <p:spTgt spid="2">
+                                            <p:txEl>
+                                              <p:pRg st="2" end="2"/>
+                                            </p:txEl>
+                                          </p:spTgt>
+                                        </p:tgtEl>
+                                        <p:attrNameLst>
+                                          <p:attrName>style.visibility</p:attrName>
+                                        </p:attrNameLst>
+                                      </p:cBhvr>
+                                      <p:to>
+                                        <p:strVal val="visible"/>
+                                      </p:to>
+                                    </p:set>
+                                  </p:childTnLst>
+                                </p:cTn>
+                              </p:par>
+                            </p:childTnLst>
+                          </p:cTn>
+                        </p:par>
+                      </p:childTnLst>
+                    </p:cTn>
+                  </p:par>
+                  <p:par>
+                    <p:cTn id="15" fill="hold">
+                      <p:stCondLst>
+                        <p:cond delay="indefinite"/>
+                      </p:stCondLst>
+                      <p:childTnLst>
+                        <p:par>
+                          <p:cTn id="16" fill="hold">
+                            <p:stCondLst>
+                              <p:cond delay="0"/>
+                            </p:stCondLst>
+                            <p:childTnLst>
+                              <p:par>
+                                <p:cTn id="17" presetID="1" presetClass="entr" presetSubtype="0" fill="hold" grpId="0" nodeType="clickEffect">
+                                  <p:stCondLst>
+                                    <p:cond delay="0"/>
+                                  </p:stCondLst>
+                                  <p:childTnLst>
+                                    <p:set>
+                                      <p:cBhvr>
+                                        <p:cTn id="18" dur="1" fill="hold">
+                                          <p:stCondLst>
+                                            <p:cond delay="0"/>
+                                          </p:stCondLst>
+                                        </p:cTn>
+                                        <p:tgtEl>
+                                          <p:spTgt spid="2">
+                                            <p:txEl>
+                                              <p:pRg st="3" end="3"/>
+                                            </p:txEl>
+                                          </p:spTgt>
+                                        </p:tgtEl>
+                                        <p:attrNameLst>
+                                          <p:attrName>style.visibility</p:attrName>
+                                        </p:attrNameLst>
+                                      </p:cBhvr>
+                                      <p:to>
+                                        <p:strVal val="visible"/>
+                                      </p:to>
+                                    </p:set>
+                                  </p:childTnLst>
+                                </p:cTn>
+                              </p:par>
+                            </p:childTnLst>
+                          </p:cTn>
+                        </p:par>
+                      </p:childTnLst>
+                    </p:cTn>
+                  </p:par>
+                  <p:par>
+                    <p:cTn id="19" fill="hold">
+                      <p:stCondLst>
+                        <p:cond delay="indefinite"/>
+                      </p:stCondLst>
+                      <p:childTnLst>
+                        <p:par>
+                          <p:cTn id="20" fill="hold">
+                            <p:stCondLst>
+                              <p:cond delay="0"/>
+                            </p:stCondLst>
+                            <p:childTnLst>
+                              <p:par>
+                                <p:cTn id="21" presetID="1" presetClass="entr" presetSubtype="0" fill="hold" grpId="0" nodeType="clickEffect">
+                                  <p:stCondLst>
+                                    <p:cond delay="0"/>
+                                  </p:stCondLst>
+                                  <p:childTnLst>
+                                    <p:set>
+                                      <p:cBhvr>
+                                        <p:cTn id="22" dur="1" fill="hold">
+                                          <p:stCondLst>
+                                            <p:cond delay="0"/>
+                                          </p:stCondLst>
+                                        </p:cTn>
+                                        <p:tgtEl>
+                                          <p:spTgt spid="2">
+                                            <p:txEl>
+                                              <p:pRg st="4" end="4"/>
+                                            </p:txEl>
+                                          </p:spTgt>
+                                        </p:tgtEl>
+                                        <p:attrNameLst>
+                                          <p:attrName>style.visibility</p:attrName>
+                                        </p:attrNameLst>
+                                      </p:cBhvr>
+                                      <p:to>
+                                        <p:strVal val="visible"/>
+                                      </p:to>
+                                    </p:set>
+                                  </p:childTnLst>
+                                </p:cTn>
+                              </p:par>
+                            </p:childTnLst>
+                          </p:cTn>
+                        </p:par>
+                      </p:childTnLst>
+                    </p:cTn>
+                  </p:par>
+                  <p:par>
+                    <p:cTn id="23" fill="hold">
+                      <p:stCondLst>
+                        <p:cond delay="indefinite"/>
+                      </p:stCondLst>
+                      <p:childTnLst>
+                        <p:par>
+                          <p:cTn id="24" fill="hold">
+                            <p:stCondLst>
+                              <p:cond delay="0"/>
+                            </p:stCondLst>
+                            <p:childTnLst>
+                              <p:par>
+                                <p:cTn id="25" presetID="1" presetClass="entr" presetSubtype="0" fill="hold" grpId="0" nodeType="clickEffect">
+                                  <p:stCondLst>
+                                    <p:cond delay="0"/>
+                                  </p:stCondLst>
+                                  <p:childTnLst>
+                                    <p:set>
+                                      <p:cBhvr>
+                                        <p:cTn id="26" dur="1" fill="hold">
+                                          <p:stCondLst>
+                                            <p:cond delay="0"/>
+                                          </p:stCondLst>
+                                        </p:cTn>
+                                        <p:tgtEl>
+                                          <p:spTgt spid="2">
+                                            <p:txEl>
+                                              <p:pRg st="5" end="5"/>
+                                            </p:txEl>
+                                          </p:spTgt>
+                                        </p:tgtEl>
+                                        <p:attrNameLst>
+                                          <p:attrName>style.visibility</p:attrName>
+                                        </p:attrNameLst>
+                                      </p:cBhvr>
+                                      <p:to>
+                                        <p:strVal val="visible"/>
+                                      </p:to>
+                                    </p:set>
+                                  </p:childTnLst>
+                                </p:cTn>
+                              </p:par>
+                            </p:childTnLst>
+                          </p:cTn>
+                        </p:par>
+                      </p:childTnLst>
+                    </p:cTn>
+                  </p:par>
+                </p:childTnLst>
+              </p:cTn>
+              <p:prevCondLst>
+                <p:cond evt="onPrev" delay="0">
+                  <p:tgtEl>
+                    <p:sldTgt/>
+                  </p:tgtEl>
+                </p:cond>
+              </p:prevCondLst>
+              <p:nextCondLst>
+                <p:cond evt="onNext" delay="0">
+                  <p:tgtEl>
+                    <p:sldTgt/>
+                  </p:tgtEl>
+                </p:cond>
+              </p:nextCondLst>
+            </p:seq>
+          </p:childTnLst>
+        </p:cTn>
+      </p:par>
+    </p:tnLst>
+    <p:bldLst>
+      <p:bldP spid="2" grpId="0" uiExpand="1" build="p"/>
+    </p:bldLst>
+  </p:timing>
+</p:sld>
+</file>
+
+<file path=ppt/slides/slide4.xml><?xml version="1.0" encoding="utf-8"?>
+<p:sld xmlns:a="http://schemas.openxmlformats.org/drawingml/2006/main" xmlns:r="http://schemas.openxmlformats.org/officeDocument/2006/relationships" xmlns:p="http://schemas.openxmlformats.org/presentationml/2006/main">
+  <p:cSld>
+    <p:spTree>
+      <p:nvGrpSpPr>
+        <p:cNvPr id="1" name="">
+          <a:extLst>
+            <a:ext uri="{FF2B5EF4-FFF2-40B4-BE49-F238E27FC236}">
+              <a16:creationId xmlns:a16="http://schemas.microsoft.com/office/drawing/2014/main" id="{CBE2D7CD-C158-6FC1-06C7-09444D2DE02B}"/>
+            </a:ext>
+          </a:extLst>
+        </p:cNvPr>
+        <p:cNvGrpSpPr/>
+        <p:nvPr/>
+      </p:nvGrpSpPr>
+      <p:grpSpPr>
+        <a:xfrm>
+          <a:off x="0" y="0"/>
+          <a:ext cx="0" cy="0"/>
+          <a:chOff x="0" y="0"/>
+          <a:chExt cx="0" cy="0"/>
+        </a:xfrm>
+      </p:grpSpPr>
+      <p:sp>
+        <p:nvSpPr>
+          <p:cNvPr id="2" name="Text Placeholder 1">
+            <a:extLst>
+              <a:ext uri="{FF2B5EF4-FFF2-40B4-BE49-F238E27FC236}">
+                <a16:creationId xmlns:a16="http://schemas.microsoft.com/office/drawing/2014/main" id="{D325C8EF-A5DD-AB22-0372-51B9ABE63526}"/>
+              </a:ext>
+            </a:extLst>
+          </p:cNvPr>
+          <p:cNvSpPr>
+            <a:spLocks noGrp="1"/>
+          </p:cNvSpPr>
+          <p:nvPr>
+            <p:ph type="body" sz="quarter" idx="13"/>
+          </p:nvPr>
+        </p:nvSpPr>
+        <p:spPr>
+          <a:xfrm>
+            <a:off x="255996" y="1271219"/>
+            <a:ext cx="10624338" cy="4142989"/>
+          </a:xfrm>
+        </p:spPr>
+        <p:txBody>
+          <a:bodyPr/>
+          <a:lstStyle/>
+          <a:p>
+            <a:pPr marL="342900" lvl="0" indent="-342900"/>
+            <a:r>
+              <a:rPr lang="en-IN" sz="2400" dirty="0">
+                <a:latin typeface="+mn-lt"/>
+              </a:rPr>
+              <a:t>Analysis: Signal preprocessing, feature extraction, condition assessment, and bearing fault identification. </a:t>
+            </a:r>
+          </a:p>
+          <a:p>
+            <a:pPr marL="342900" lvl="0" indent="-342900"/>
+            <a:r>
+              <a:rPr lang="en-IN" sz="2400" dirty="0">
+                <a:latin typeface="+mn-lt"/>
+              </a:rPr>
+              <a:t>Fault Diagnosis: Classification of bearing health conditions based on characteristic vibration patterns and degradation </a:t>
+            </a:r>
+            <a:r>
+              <a:rPr lang="en-IN" sz="2400" dirty="0" err="1">
+                <a:latin typeface="+mn-lt"/>
+              </a:rPr>
+              <a:t>behavior</a:t>
+            </a:r>
+            <a:r>
+              <a:rPr lang="en-IN" sz="2400" dirty="0">
+                <a:latin typeface="+mn-lt"/>
+              </a:rPr>
+              <a:t>. </a:t>
+            </a:r>
+          </a:p>
+          <a:p>
+            <a:pPr marL="342900" lvl="0" indent="-342900"/>
+            <a:r>
+              <a:rPr lang="en-IN" sz="2400" dirty="0">
+                <a:latin typeface="+mn-lt"/>
+              </a:rPr>
+              <a:t>AI Agent: Development of a deterministic MCP-based workflow for structured and repeatable diagnostic reasoning. </a:t>
+            </a:r>
+          </a:p>
+          <a:p>
+            <a:pPr marL="342900" lvl="0" indent="-342900"/>
+            <a:r>
+              <a:rPr lang="en-IN" sz="2400" dirty="0">
+                <a:latin typeface="+mn-lt"/>
+              </a:rPr>
+              <a:t>Standards: Use of relevant ISO standards for vibration measurement, evaluation, and machine condition monitoring. </a:t>
+            </a:r>
+          </a:p>
+          <a:p>
+            <a:pPr marL="342900" lvl="0" indent="-342900"/>
+            <a:r>
+              <a:rPr lang="en-IN" sz="2400" dirty="0">
+                <a:latin typeface="+mn-lt"/>
+              </a:rPr>
+              <a:t>Output: A clear diagnostic result with an explainable and reproducible basis for the identified bearing condition. </a:t>
+            </a:r>
+          </a:p>
+          <a:p>
+            <a:pPr marL="342900" lvl="0" indent="-342900"/>
+            <a:r>
+              <a:rPr lang="en-IN" sz="2400" dirty="0">
+                <a:latin typeface="+mn-lt"/>
+              </a:rPr>
+              <a:t>Application: Supporting predictive maintenance and reliability-</a:t>
+            </a:r>
+            <a:r>
+              <a:rPr lang="en-IN" sz="2400" dirty="0" err="1">
+                <a:latin typeface="+mn-lt"/>
+              </a:rPr>
+              <a:t>centered</a:t>
+            </a:r>
+            <a:r>
+              <a:rPr lang="en-IN" sz="2400" dirty="0">
+                <a:latin typeface="+mn-lt"/>
+              </a:rPr>
+              <a:t> decision-making for rotating machinery.</a:t>
+            </a:r>
+          </a:p>
+          <a:p>
+            <a:pPr marL="0" indent="0">
+              <a:lnSpc>
+                <a:spcPct val="150000"/>
+              </a:lnSpc>
+              <a:buNone/>
+            </a:pPr>
+            <a:endParaRPr lang="en-US" sz="2400" b="0" dirty="0">
+              <a:solidFill>
+                <a:srgbClr val="5583D1"/>
+              </a:solidFill>
+              <a:latin typeface="+mn-lt"/>
+            </a:endParaRPr>
+          </a:p>
+        </p:txBody>
+      </p:sp>
+      <p:sp>
+        <p:nvSpPr>
+          <p:cNvPr id="3" name="TextBox 2">
+            <a:extLst>
+              <a:ext uri="{FF2B5EF4-FFF2-40B4-BE49-F238E27FC236}">
+                <a16:creationId xmlns:a16="http://schemas.microsoft.com/office/drawing/2014/main" id="{CB15F4B8-EED0-F7BE-96C7-D7AAE989A251}"/>
+              </a:ext>
+            </a:extLst>
+          </p:cNvPr>
+          <p:cNvSpPr txBox="1"/>
+          <p:nvPr/>
+        </p:nvSpPr>
+        <p:spPr>
+          <a:xfrm>
+            <a:off x="255996" y="502545"/>
+            <a:ext cx="10624338" cy="646331"/>
+          </a:xfrm>
+          <a:prstGeom prst="rect">
+            <a:avLst/>
+          </a:prstGeom>
+          <a:noFill/>
+        </p:spPr>
+        <p:txBody>
+          <a:bodyPr wrap="square" rtlCol="0">
+            <a:spAutoFit/>
+          </a:bodyPr>
+          <a:lstStyle/>
+          <a:p>
+            <a:pPr marL="0" marR="0" lvl="0" indent="0" algn="l" defTabSz="914400" rtl="0" eaLnBrk="1" fontAlgn="auto" latinLnBrk="0" hangingPunct="1">
+              <a:lnSpc>
+                <a:spcPct val="100000"/>
+              </a:lnSpc>
+              <a:spcBef>
+                <a:spcPts val="0"/>
+              </a:spcBef>
+              <a:spcAft>
+                <a:spcPts val="0"/>
+              </a:spcAft>
+              <a:buClrTx/>
+              <a:buSzTx/>
+              <a:buFontTx/>
+              <a:buNone/>
+              <a:tabLst/>
+              <a:defRPr/>
+            </a:pPr>
+            <a:r>
+              <a:rPr kumimoji="0" lang="en-US" sz="3600" b="1" i="0" u="none" strike="noStrike" kern="1200" cap="none" spc="0" normalizeH="0" baseline="0" noProof="0" dirty="0">
+                <a:ln>
+                  <a:noFill/>
+                </a:ln>
+                <a:solidFill>
+                  <a:srgbClr val="5B9BD5">
+                    <a:lumMod val="50000"/>
+                  </a:srgbClr>
+                </a:solidFill>
+                <a:effectLst/>
+                <a:uLnTx/>
+                <a:uFillTx/>
+                <a:latin typeface="Calibri" panose="020F0502020204030204"/>
+                <a:ea typeface="+mn-ea"/>
+                <a:cs typeface="+mn-cs"/>
+              </a:rPr>
+              <a:t>Scope</a:t>
+            </a:r>
+          </a:p>
+        </p:txBody>
+      </p:sp>
+      <p:cxnSp>
+        <p:nvCxnSpPr>
+          <p:cNvPr id="5" name="Straight Connector 4">
+            <a:extLst>
+              <a:ext uri="{FF2B5EF4-FFF2-40B4-BE49-F238E27FC236}">
+                <a16:creationId xmlns:a16="http://schemas.microsoft.com/office/drawing/2014/main" id="{5A882B44-FCE4-BF93-E951-46CF2238FB74}"/>
+              </a:ext>
+            </a:extLst>
+          </p:cNvPr>
+          <p:cNvCxnSpPr>
+            <a:cxnSpLocks/>
+          </p:cNvCxnSpPr>
+          <p:nvPr/>
+        </p:nvCxnSpPr>
+        <p:spPr>
+          <a:xfrm>
+            <a:off x="221274" y="1191756"/>
+            <a:ext cx="7305799" cy="0"/>
+          </a:xfrm>
+          <a:prstGeom prst="line">
+            <a:avLst/>
+          </a:prstGeom>
+          <a:ln w="28575">
+            <a:solidFill>
+              <a:schemeClr val="accent6"/>
+            </a:solidFill>
+          </a:ln>
+        </p:spPr>
+        <p:style>
+          <a:lnRef idx="1">
+            <a:schemeClr val="accent1"/>
+          </a:lnRef>
+          <a:fillRef idx="0">
+            <a:schemeClr val="accent1"/>
+          </a:fillRef>
+          <a:effectRef idx="0">
+            <a:schemeClr val="accent1"/>
+          </a:effectRef>
+          <a:fontRef idx="minor">
+            <a:schemeClr val="tx1"/>
+          </a:fontRef>
+        </p:style>
+      </p:cxnSp>
+      <p:sp>
+        <p:nvSpPr>
+          <p:cNvPr id="4" name="TextBox 3">
+            <a:extLst>
+              <a:ext uri="{FF2B5EF4-FFF2-40B4-BE49-F238E27FC236}">
+                <a16:creationId xmlns:a16="http://schemas.microsoft.com/office/drawing/2014/main" id="{6CE164B1-01DD-BF3B-88E8-DF2DEDBFA9EB}"/>
+              </a:ext>
+            </a:extLst>
+          </p:cNvPr>
+          <p:cNvSpPr txBox="1"/>
+          <p:nvPr/>
+        </p:nvSpPr>
+        <p:spPr>
+          <a:xfrm>
+            <a:off x="4898571" y="57036"/>
+            <a:ext cx="7293429" cy="369332"/>
+          </a:xfrm>
+          <a:prstGeom prst="rect">
+            <a:avLst/>
+          </a:prstGeom>
+          <a:noFill/>
+        </p:spPr>
+        <p:txBody>
+          <a:bodyPr wrap="square" rtlCol="0">
+            <a:spAutoFit/>
+          </a:bodyPr>
+          <a:lstStyle/>
+          <a:p>
+            <a:pPr lvl="0" algn="ctr">
+              <a:defRPr/>
+            </a:pPr>
+            <a:r>
+              <a:rPr lang="en-GB" b="1" dirty="0">
+                <a:solidFill>
+                  <a:prstClr val="white"/>
+                </a:solidFill>
+                <a:cs typeface="Calibri" panose="020F0502020204030204" pitchFamily="34" charset="0"/>
+              </a:rPr>
+              <a:t>Deterministic MCP-Driven AI Agents for Ball Bearing Vibration Diagnostics</a:t>
+            </a:r>
+            <a:endParaRPr lang="en-US" b="1" dirty="0">
+              <a:solidFill>
+                <a:prstClr val="white"/>
+              </a:solidFill>
+              <a:cs typeface="Calibri" panose="020F0502020204030204" pitchFamily="34" charset="0"/>
+            </a:endParaRPr>
+          </a:p>
+        </p:txBody>
+      </p:sp>
+    </p:spTree>
+    <p:extLst>
+      <p:ext uri="{BB962C8B-B14F-4D97-AF65-F5344CB8AC3E}">
+        <p14:creationId xmlns:p14="http://schemas.microsoft.com/office/powerpoint/2010/main" val="2034681921"/>
+      </p:ext>
+    </p:extLst>
+  </p:cSld>
+  <p:clrMapOvr>
+    <a:masterClrMapping/>
+  </p:clrMapOvr>
+  <mc:AlternateContent xmlns:mc="http://schemas.openxmlformats.org/markup-compatibility/2006" xmlns:p14="http://schemas.microsoft.com/office/powerpoint/2010/main">
+    <mc:Choice Requires="p14">
+      <p:transition spd="med" p14:dur="700">
+        <p:fade/>
+      </p:transition>
+    </mc:Choice>
+    <mc:Fallback xmlns="">
+      <p:transition spd="med">
+        <p:fade/>
+      </p:transition>
+    </mc:Fallback>
+  </mc:AlternateContent>
+  <p:timing>
+    <p:tnLst>
+      <p:par>
+        <p:cTn id="1" dur="indefinite" restart="never" nodeType="tmRoot">
+          <p:childTnLst>
+            <p:seq concurrent="1" nextAc="seek">
+              <p:cTn id="2" dur="indefinite" nodeType="mainSeq">
+                <p:childTnLst>
+                  <p:par>
+                    <p:cTn id="3" fill="hold">
+                      <p:stCondLst>
+                        <p:cond delay="indefinite"/>
+                      </p:stCondLst>
+                      <p:childTnLst>
+                        <p:par>
+                          <p:cTn id="4" fill="hold">
+                            <p:stCondLst>
+                              <p:cond delay="0"/>
+                            </p:stCondLst>
+                            <p:childTnLst>
+                              <p:par>
+                                <p:cTn id="5" presetID="1" presetClass="entr" presetSubtype="0" fill="hold" grpId="0" nodeType="clickEffect">
+                                  <p:stCondLst>
+                                    <p:cond delay="0"/>
+                                  </p:stCondLst>
+                                  <p:childTnLst>
+                                    <p:set>
+                                      <p:cBhvr>
+                                        <p:cTn id="6" dur="1" fill="hold">
+                                          <p:stCondLst>
+                                            <p:cond delay="0"/>
+                                          </p:stCondLst>
+                                        </p:cTn>
+                                        <p:tgtEl>
+                                          <p:spTgt spid="2">
+                                            <p:txEl>
+                                              <p:pRg st="0" end="0"/>
+                                            </p:txEl>
+                                          </p:spTgt>
+                                        </p:tgtEl>
+                                        <p:attrNameLst>
+                                          <p:attrName>style.visibility</p:attrName>
+                                        </p:attrNameLst>
+                                      </p:cBhvr>
+                                      <p:to>
+                                        <p:strVal val="visible"/>
+                                      </p:to>
+                                    </p:set>
+                                  </p:childTnLst>
+                                </p:cTn>
+                              </p:par>
+                            </p:childTnLst>
+                          </p:cTn>
+                        </p:par>
+                      </p:childTnLst>
+                    </p:cTn>
+                  </p:par>
+                  <p:par>
+                    <p:cTn id="7" fill="hold">
+                      <p:stCondLst>
+                        <p:cond delay="indefinite"/>
+                      </p:stCondLst>
+                      <p:childTnLst>
+                        <p:par>
+                          <p:cTn id="8" fill="hold">
+                            <p:stCondLst>
+                              <p:cond delay="0"/>
+                            </p:stCondLst>
+                            <p:childTnLst>
+                              <p:par>
+                                <p:cTn id="9" presetID="1" presetClass="entr" presetSubtype="0" fill="hold" grpId="0" nodeType="clickEffect">
+                                  <p:stCondLst>
+                                    <p:cond delay="0"/>
+                                  </p:stCondLst>
+                                  <p:childTnLst>
+                                    <p:set>
+                                      <p:cBhvr>
+                                        <p:cTn id="10" dur="1" fill="hold">
+                                          <p:stCondLst>
+                                            <p:cond delay="0"/>
+                                          </p:stCondLst>
+                                        </p:cTn>
+                                        <p:tgtEl>
+                                          <p:spTgt spid="2">
+                                            <p:txEl>
+                                              <p:pRg st="1" end="1"/>
+                                            </p:txEl>
+                                          </p:spTgt>
+                                        </p:tgtEl>
+                                        <p:attrNameLst>
+                                          <p:attrName>style.visibility</p:attrName>
+                                        </p:attrNameLst>
+                                      </p:cBhvr>
+                                      <p:to>
+                                        <p:strVal val="visible"/>
+                                      </p:to>
+                                    </p:set>
+                                  </p:childTnLst>
+                                </p:cTn>
+                              </p:par>
+                            </p:childTnLst>
+                          </p:cTn>
+                        </p:par>
+                      </p:childTnLst>
+                    </p:cTn>
+                  </p:par>
+                  <p:par>
+                    <p:cTn id="11" fill="hold">
+                      <p:stCondLst>
+                        <p:cond delay="indefinite"/>
+                      </p:stCondLst>
+                      <p:childTnLst>
+                        <p:par>
+                          <p:cTn id="12" fill="hold">
+                            <p:stCondLst>
+                              <p:cond delay="0"/>
+                            </p:stCondLst>
+                            <p:childTnLst>
+                              <p:par>
+                                <p:cTn id="13" presetID="1" presetClass="entr" presetSubtype="0" fill="hold" grpId="0" nodeType="clickEffect">
+                                  <p:stCondLst>
+                                    <p:cond delay="0"/>
+                                  </p:stCondLst>
+                                  <p:childTnLst>
+                                    <p:set>
+                                      <p:cBhvr>
+                                        <p:cTn id="14" dur="1" fill="hold">
+                                          <p:stCondLst>
+                                            <p:cond delay="0"/>
+                                          </p:stCondLst>
+                                        </p:cTn>
+                                        <p:tgtEl>
+                                          <p:spTgt spid="2">
+                                            <p:txEl>
+                                              <p:pRg st="2" end="2"/>
+                                            </p:txEl>
+                                          </p:spTgt>
+                                        </p:tgtEl>
+                                        <p:attrNameLst>
+                                          <p:attrName>style.visibility</p:attrName>
+                                        </p:attrNameLst>
+                                      </p:cBhvr>
+                                      <p:to>
+                                        <p:strVal val="visible"/>
+                                      </p:to>
+                                    </p:set>
+                                  </p:childTnLst>
+                                </p:cTn>
+                              </p:par>
+                            </p:childTnLst>
+                          </p:cTn>
+                        </p:par>
+                      </p:childTnLst>
+                    </p:cTn>
+                  </p:par>
+                  <p:par>
+                    <p:cTn id="15" fill="hold">
+                      <p:stCondLst>
+                        <p:cond delay="indefinite"/>
+                      </p:stCondLst>
+                      <p:childTnLst>
+                        <p:par>
+                          <p:cTn id="16" fill="hold">
+                            <p:stCondLst>
+                              <p:cond delay="0"/>
+                            </p:stCondLst>
+                            <p:childTnLst>
+                              <p:par>
+                                <p:cTn id="17" presetID="1" presetClass="entr" presetSubtype="0" fill="hold" grpId="0" nodeType="clickEffect">
+                                  <p:stCondLst>
+                                    <p:cond delay="0"/>
+                                  </p:stCondLst>
+                                  <p:childTnLst>
+                                    <p:set>
+                                      <p:cBhvr>
+                                        <p:cTn id="18" dur="1" fill="hold">
+                                          <p:stCondLst>
+                                            <p:cond delay="0"/>
+                                          </p:stCondLst>
+                                        </p:cTn>
+                                        <p:tgtEl>
+                                          <p:spTgt spid="2">
+                                            <p:txEl>
+                                              <p:pRg st="3" end="3"/>
+                                            </p:txEl>
+                                          </p:spTgt>
+                                        </p:tgtEl>
+                                        <p:attrNameLst>
+                                          <p:attrName>style.visibility</p:attrName>
+                                        </p:attrNameLst>
+                                      </p:cBhvr>
+                                      <p:to>
+                                        <p:strVal val="visible"/>
+                                      </p:to>
+                                    </p:set>
+                                  </p:childTnLst>
+                                </p:cTn>
+                              </p:par>
+                            </p:childTnLst>
+                          </p:cTn>
+                        </p:par>
+                      </p:childTnLst>
+                    </p:cTn>
+                  </p:par>
+                  <p:par>
+                    <p:cTn id="19" fill="hold">
+                      <p:stCondLst>
+                        <p:cond delay="indefinite"/>
+                      </p:stCondLst>
+                      <p:childTnLst>
+                        <p:par>
+                          <p:cTn id="20" fill="hold">
+                            <p:stCondLst>
+                              <p:cond delay="0"/>
+                            </p:stCondLst>
+                            <p:childTnLst>
+                              <p:par>
+                                <p:cTn id="21" presetID="1" presetClass="entr" presetSubtype="0" fill="hold" grpId="0" nodeType="clickEffect">
+                                  <p:stCondLst>
+                                    <p:cond delay="0"/>
+                                  </p:stCondLst>
+                                  <p:childTnLst>
+                                    <p:set>
+                                      <p:cBhvr>
+                                        <p:cTn id="22" dur="1" fill="hold">
+                                          <p:stCondLst>
+                                            <p:cond delay="0"/>
+                                          </p:stCondLst>
+                                        </p:cTn>
+                                        <p:tgtEl>
+                                          <p:spTgt spid="2">
+                                            <p:txEl>
+                                              <p:pRg st="4" end="4"/>
+                                            </p:txEl>
+                                          </p:spTgt>
+                                        </p:tgtEl>
+                                        <p:attrNameLst>
+                                          <p:attrName>style.visibility</p:attrName>
+                                        </p:attrNameLst>
+                                      </p:cBhvr>
+                                      <p:to>
+                                        <p:strVal val="visible"/>
+                                      </p:to>
+                                    </p:set>
+                                  </p:childTnLst>
+                                </p:cTn>
+                              </p:par>
+                            </p:childTnLst>
+                          </p:cTn>
+                        </p:par>
+                      </p:childTnLst>
+                    </p:cTn>
+                  </p:par>
+                  <p:par>
+                    <p:cTn id="23" fill="hold">
+                      <p:stCondLst>
+                        <p:cond delay="indefinite"/>
+                      </p:stCondLst>
+                      <p:childTnLst>
+                        <p:par>
+                          <p:cTn id="24" fill="hold">
+                            <p:stCondLst>
+                              <p:cond delay="0"/>
+                            </p:stCondLst>
+                            <p:childTnLst>
+                              <p:par>
+                                <p:cTn id="25" presetID="1" presetClass="entr" presetSubtype="0" fill="hold" grpId="0" nodeType="clickEffect">
+                                  <p:stCondLst>
+                                    <p:cond delay="0"/>
+                                  </p:stCondLst>
+                                  <p:childTnLst>
+                                    <p:set>
+                                      <p:cBhvr>
+                                        <p:cTn id="26" dur="1" fill="hold">
+                                          <p:stCondLst>
+                                            <p:cond delay="0"/>
+                                          </p:stCondLst>
+                                        </p:cTn>
+                                        <p:tgtEl>
+                                          <p:spTgt spid="2">
+                                            <p:txEl>
+                                              <p:pRg st="5" end="5"/>
+                                            </p:txEl>
+                                          </p:spTgt>
+                                        </p:tgtEl>
+                                        <p:attrNameLst>
+                                          <p:attrName>style.visibility</p:attrName>
+                                        </p:attrNameLst>
+                                      </p:cBhvr>
+                                      <p:to>
+                                        <p:strVal val="visible"/>
+                                      </p:to>
+                                    </p:set>
+                                  </p:childTnLst>
+                                </p:cTn>
+                              </p:par>
+                            </p:childTnLst>
+                          </p:cTn>
+                        </p:par>
+                      </p:childTnLst>
+                    </p:cTn>
+                  </p:par>
+                </p:childTnLst>
+              </p:cTn>
+              <p:prevCondLst>
+                <p:cond evt="onPrev" delay="0">
+                  <p:tgtEl>
+                    <p:sldTgt/>
+                  </p:tgtEl>
+                </p:cond>
+              </p:prevCondLst>
+              <p:nextCondLst>
+                <p:cond evt="onNext" delay="0">
+                  <p:tgtEl>
+                    <p:sldTgt/>
+                  </p:tgtEl>
+                </p:cond>
+              </p:nextCondLst>
+            </p:seq>
+          </p:childTnLst>
+        </p:cTn>
+      </p:par>
+    </p:tnLst>
+    <p:bldLst>
+      <p:bldP spid="2" grpId="0" uiExpand="1" build="p"/>
+    </p:bldLst>
+  </p:timing>
+</p:sld>
+</file>
+
+<file path=ppt/slides/slide5.xml><?xml version="1.0" encoding="utf-8"?>
 <p:sld xmlns:a="http://schemas.openxmlformats.org/drawingml/2006/main" xmlns:r="http://schemas.openxmlformats.org/officeDocument/2006/relationships" xmlns:p="http://schemas.openxmlformats.org/presentationml/2006/main">
   <p:cSld>
     <p:spTree>
@@ -7855,7 +7477,7 @@
 </p:sld>
 </file>
 
-<file path=ppt/slides/slide7.xml><?xml version="1.0" encoding="utf-8"?>
+<file path=ppt/slides/slide6.xml><?xml version="1.0" encoding="utf-8"?>
 <p:sld xmlns:a="http://schemas.openxmlformats.org/drawingml/2006/main" xmlns:r="http://schemas.openxmlformats.org/officeDocument/2006/relationships" xmlns:p="http://schemas.openxmlformats.org/presentationml/2006/main">
   <p:cSld>
     <p:spTree>
@@ -8100,7 +7722,7 @@
 </p:sld>
 </file>
 
-<file path=ppt/slides/slide8.xml><?xml version="1.0" encoding="utf-8"?>
+<file path=ppt/slides/slide7.xml><?xml version="1.0" encoding="utf-8"?>
 <p:sld xmlns:a="http://schemas.openxmlformats.org/drawingml/2006/main" xmlns:r="http://schemas.openxmlformats.org/officeDocument/2006/relationships" xmlns:p="http://schemas.openxmlformats.org/presentationml/2006/main">
   <p:cSld>
     <p:spTree>
@@ -8405,7 +8027,7 @@
 </p:sld>
 </file>
 
-<file path=ppt/slides/slide9.xml><?xml version="1.0" encoding="utf-8"?>
+<file path=ppt/slides/slide8.xml><?xml version="1.0" encoding="utf-8"?>
 <p:sld xmlns:a="http://schemas.openxmlformats.org/drawingml/2006/main" xmlns:r="http://schemas.openxmlformats.org/officeDocument/2006/relationships" xmlns:p="http://schemas.openxmlformats.org/presentationml/2006/main">
   <p:cSld>
     <p:spTree>
@@ -8885,6 +8507,465 @@
     <p:extLst>
       <p:ext uri="{BB962C8B-B14F-4D97-AF65-F5344CB8AC3E}">
         <p14:creationId xmlns:p14="http://schemas.microsoft.com/office/powerpoint/2010/main" val="3613685866"/>
+      </p:ext>
+    </p:extLst>
+  </p:cSld>
+  <p:clrMapOvr>
+    <a:masterClrMapping/>
+  </p:clrMapOvr>
+  <mc:AlternateContent xmlns:mc="http://schemas.openxmlformats.org/markup-compatibility/2006" xmlns:p14="http://schemas.microsoft.com/office/powerpoint/2010/main">
+    <mc:Choice Requires="p14">
+      <p:transition spd="med" p14:dur="700">
+        <p:fade/>
+      </p:transition>
+    </mc:Choice>
+    <mc:Fallback xmlns="">
+      <p:transition spd="med">
+        <p:fade/>
+      </p:transition>
+    </mc:Fallback>
+  </mc:AlternateContent>
+</p:sld>
+</file>
+
+<file path=ppt/slides/slide9.xml><?xml version="1.0" encoding="utf-8"?>
+<p:sld xmlns:a="http://schemas.openxmlformats.org/drawingml/2006/main" xmlns:r="http://schemas.openxmlformats.org/officeDocument/2006/relationships" xmlns:p="http://schemas.openxmlformats.org/presentationml/2006/main">
+  <p:cSld>
+    <p:spTree>
+      <p:nvGrpSpPr>
+        <p:cNvPr id="1" name=""/>
+        <p:cNvGrpSpPr/>
+        <p:nvPr/>
+      </p:nvGrpSpPr>
+      <p:grpSpPr>
+        <a:xfrm>
+          <a:off x="0" y="0"/>
+          <a:ext cx="0" cy="0"/>
+          <a:chOff x="0" y="0"/>
+          <a:chExt cx="0" cy="0"/>
+        </a:xfrm>
+      </p:grpSpPr>
+      <p:sp>
+        <p:nvSpPr>
+          <p:cNvPr id="3" name="TextBox 2">
+            <a:extLst>
+              <a:ext uri="{FF2B5EF4-FFF2-40B4-BE49-F238E27FC236}">
+                <a16:creationId xmlns:a16="http://schemas.microsoft.com/office/drawing/2014/main" id="{25EA9B7F-B60D-6297-DC95-0FDA7E6D7C7C}"/>
+              </a:ext>
+            </a:extLst>
+          </p:cNvPr>
+          <p:cNvSpPr txBox="1"/>
+          <p:nvPr/>
+        </p:nvSpPr>
+        <p:spPr>
+          <a:xfrm>
+            <a:off x="255996" y="502545"/>
+            <a:ext cx="10624338" cy="646331"/>
+          </a:xfrm>
+          <a:prstGeom prst="rect">
+            <a:avLst/>
+          </a:prstGeom>
+          <a:noFill/>
+        </p:spPr>
+        <p:txBody>
+          <a:bodyPr wrap="square" rtlCol="0">
+            <a:spAutoFit/>
+          </a:bodyPr>
+          <a:lstStyle/>
+          <a:p>
+            <a:pPr marL="0" marR="0" lvl="0" indent="0" algn="l" defTabSz="914400" rtl="0" eaLnBrk="1" fontAlgn="auto" latinLnBrk="0" hangingPunct="1">
+              <a:lnSpc>
+                <a:spcPct val="100000"/>
+              </a:lnSpc>
+              <a:spcBef>
+                <a:spcPts val="0"/>
+              </a:spcBef>
+              <a:spcAft>
+                <a:spcPts val="0"/>
+              </a:spcAft>
+              <a:buClrTx/>
+              <a:buSzTx/>
+              <a:buFontTx/>
+              <a:buNone/>
+              <a:tabLst/>
+              <a:defRPr/>
+            </a:pPr>
+            <a:r>
+              <a:rPr kumimoji="0" lang="en-US" sz="3600" b="1" i="0" u="none" strike="noStrike" kern="1200" cap="none" spc="0" normalizeH="0" baseline="0" noProof="0" dirty="0">
+                <a:ln>
+                  <a:noFill/>
+                </a:ln>
+                <a:solidFill>
+                  <a:srgbClr val="5B9BD5">
+                    <a:lumMod val="50000"/>
+                  </a:srgbClr>
+                </a:solidFill>
+                <a:effectLst/>
+                <a:uLnTx/>
+                <a:uFillTx/>
+                <a:latin typeface="Calibri" panose="020F0502020204030204"/>
+                <a:ea typeface="+mn-ea"/>
+                <a:cs typeface="+mn-cs"/>
+              </a:rPr>
+              <a:t>Modules to cover</a:t>
+            </a:r>
+          </a:p>
+        </p:txBody>
+      </p:sp>
+      <p:cxnSp>
+        <p:nvCxnSpPr>
+          <p:cNvPr id="5" name="Straight Connector 4">
+            <a:extLst>
+              <a:ext uri="{FF2B5EF4-FFF2-40B4-BE49-F238E27FC236}">
+                <a16:creationId xmlns:a16="http://schemas.microsoft.com/office/drawing/2014/main" id="{25CD5B67-3503-60B5-8469-F3C3191D84D7}"/>
+              </a:ext>
+            </a:extLst>
+          </p:cNvPr>
+          <p:cNvCxnSpPr>
+            <a:cxnSpLocks/>
+          </p:cNvCxnSpPr>
+          <p:nvPr/>
+        </p:nvCxnSpPr>
+        <p:spPr>
+          <a:xfrm>
+            <a:off x="221274" y="1191756"/>
+            <a:ext cx="7305799" cy="0"/>
+          </a:xfrm>
+          <a:prstGeom prst="line">
+            <a:avLst/>
+          </a:prstGeom>
+          <a:ln w="28575">
+            <a:solidFill>
+              <a:schemeClr val="accent6"/>
+            </a:solidFill>
+          </a:ln>
+        </p:spPr>
+        <p:style>
+          <a:lnRef idx="1">
+            <a:schemeClr val="accent1"/>
+          </a:lnRef>
+          <a:fillRef idx="0">
+            <a:schemeClr val="accent1"/>
+          </a:fillRef>
+          <a:effectRef idx="0">
+            <a:schemeClr val="accent1"/>
+          </a:effectRef>
+          <a:fontRef idx="minor">
+            <a:schemeClr val="tx1"/>
+          </a:fontRef>
+        </p:style>
+      </p:cxnSp>
+      <p:sp>
+        <p:nvSpPr>
+          <p:cNvPr id="4" name="TextBox 3">
+            <a:extLst>
+              <a:ext uri="{FF2B5EF4-FFF2-40B4-BE49-F238E27FC236}">
+                <a16:creationId xmlns:a16="http://schemas.microsoft.com/office/drawing/2014/main" id="{5D4A0452-2CB8-E4C6-FAC7-ECD109C50CE1}"/>
+              </a:ext>
+            </a:extLst>
+          </p:cNvPr>
+          <p:cNvSpPr txBox="1"/>
+          <p:nvPr/>
+        </p:nvSpPr>
+        <p:spPr>
+          <a:xfrm>
+            <a:off x="4898571" y="57036"/>
+            <a:ext cx="7293429" cy="369332"/>
+          </a:xfrm>
+          <a:prstGeom prst="rect">
+            <a:avLst/>
+          </a:prstGeom>
+          <a:noFill/>
+        </p:spPr>
+        <p:txBody>
+          <a:bodyPr wrap="square" rtlCol="0">
+            <a:spAutoFit/>
+          </a:bodyPr>
+          <a:lstStyle/>
+          <a:p>
+            <a:pPr lvl="0" algn="ctr">
+              <a:defRPr/>
+            </a:pPr>
+            <a:r>
+              <a:rPr lang="en-GB" b="1" dirty="0">
+                <a:solidFill>
+                  <a:prstClr val="white"/>
+                </a:solidFill>
+                <a:cs typeface="Calibri" panose="020F0502020204030204" pitchFamily="34" charset="0"/>
+              </a:rPr>
+              <a:t>Deterministic MCP-Driven AI Agents for Ball Bearing Vibration Diagnostics</a:t>
+            </a:r>
+            <a:endParaRPr lang="en-US" b="1" dirty="0">
+              <a:solidFill>
+                <a:prstClr val="white"/>
+              </a:solidFill>
+              <a:cs typeface="Calibri" panose="020F0502020204030204" pitchFamily="34" charset="0"/>
+            </a:endParaRPr>
+          </a:p>
+        </p:txBody>
+      </p:sp>
+      <p:sp>
+        <p:nvSpPr>
+          <p:cNvPr id="6" name="TextBox 5">
+            <a:extLst>
+              <a:ext uri="{FF2B5EF4-FFF2-40B4-BE49-F238E27FC236}">
+                <a16:creationId xmlns:a16="http://schemas.microsoft.com/office/drawing/2014/main" id="{8F69BBE3-6CB4-2639-F479-D4BD440A32A4}"/>
+              </a:ext>
+            </a:extLst>
+          </p:cNvPr>
+          <p:cNvSpPr txBox="1"/>
+          <p:nvPr/>
+        </p:nvSpPr>
+        <p:spPr>
+          <a:xfrm>
+            <a:off x="6725264" y="1357505"/>
+            <a:ext cx="6098107" cy="3970318"/>
+          </a:xfrm>
+          <a:prstGeom prst="rect">
+            <a:avLst/>
+          </a:prstGeom>
+          <a:noFill/>
+        </p:spPr>
+        <p:txBody>
+          <a:bodyPr wrap="square" rtlCol="0">
+            <a:spAutoFit/>
+          </a:bodyPr>
+          <a:lstStyle/>
+          <a:p>
+            <a:pPr>
+              <a:buNone/>
+            </a:pPr>
+            <a:r>
+              <a:rPr lang="en-IN" b="1" dirty="0">
+                <a:solidFill>
+                  <a:schemeClr val="accent1"/>
+                </a:solidFill>
+              </a:rPr>
+              <a:t>4. Deterministic Diagnostic Engine</a:t>
+            </a:r>
+            <a:endParaRPr lang="en-IN" dirty="0">
+              <a:solidFill>
+                <a:schemeClr val="accent1"/>
+              </a:solidFill>
+            </a:endParaRPr>
+          </a:p>
+          <a:p>
+            <a:pPr marL="342900" lvl="0" indent="-342900">
+              <a:buFont typeface="Arial" panose="020B0604020202020204" pitchFamily="34" charset="0"/>
+              <a:buChar char="•"/>
+            </a:pPr>
+            <a:r>
+              <a:rPr lang="en-IN" dirty="0">
+                <a:solidFill>
+                  <a:schemeClr val="accent1"/>
+                </a:solidFill>
+              </a:rPr>
+              <a:t>Rule/threshold-based decision logic </a:t>
+            </a:r>
+          </a:p>
+          <a:p>
+            <a:pPr marL="342900" lvl="0" indent="-342900">
+              <a:buFont typeface="Arial" panose="020B0604020202020204" pitchFamily="34" charset="0"/>
+              <a:buChar char="•"/>
+            </a:pPr>
+            <a:r>
+              <a:rPr lang="en-IN" dirty="0">
+                <a:solidFill>
+                  <a:schemeClr val="accent1"/>
+                </a:solidFill>
+              </a:rPr>
+              <a:t>Consistent and reproducible diagnosis </a:t>
+            </a:r>
+          </a:p>
+          <a:p>
+            <a:pPr marL="342900" lvl="0" indent="-342900">
+              <a:buFont typeface="Arial" panose="020B0604020202020204" pitchFamily="34" charset="0"/>
+              <a:buChar char="•"/>
+            </a:pPr>
+            <a:r>
+              <a:rPr lang="en-IN" dirty="0">
+                <a:solidFill>
+                  <a:schemeClr val="accent1"/>
+                </a:solidFill>
+              </a:rPr>
+              <a:t>ISO-based diagnostic criteria </a:t>
+            </a:r>
+          </a:p>
+          <a:p>
+            <a:pPr lvl="0"/>
+            <a:endParaRPr lang="en-IN" dirty="0">
+              <a:solidFill>
+                <a:schemeClr val="accent1"/>
+              </a:solidFill>
+            </a:endParaRPr>
+          </a:p>
+          <a:p>
+            <a:pPr>
+              <a:buNone/>
+            </a:pPr>
+            <a:r>
+              <a:rPr lang="en-IN" b="1" dirty="0">
+                <a:solidFill>
+                  <a:schemeClr val="accent1"/>
+                </a:solidFill>
+              </a:rPr>
+              <a:t>5. MCP-Driven AI Agent</a:t>
+            </a:r>
+            <a:endParaRPr lang="en-IN" dirty="0">
+              <a:solidFill>
+                <a:schemeClr val="accent1"/>
+              </a:solidFill>
+            </a:endParaRPr>
+          </a:p>
+          <a:p>
+            <a:pPr marL="342900" lvl="0" indent="-342900">
+              <a:buFont typeface="Arial" panose="020B0604020202020204" pitchFamily="34" charset="0"/>
+              <a:buChar char="•"/>
+            </a:pPr>
+            <a:r>
+              <a:rPr lang="en-IN" dirty="0">
+                <a:solidFill>
+                  <a:schemeClr val="accent1"/>
+                </a:solidFill>
+              </a:rPr>
+              <a:t>MCP tools and structured context </a:t>
+            </a:r>
+          </a:p>
+          <a:p>
+            <a:pPr marL="342900" lvl="0" indent="-342900">
+              <a:buFont typeface="Arial" panose="020B0604020202020204" pitchFamily="34" charset="0"/>
+              <a:buChar char="•"/>
+            </a:pPr>
+            <a:r>
+              <a:rPr lang="en-IN" dirty="0">
+                <a:solidFill>
+                  <a:schemeClr val="accent1"/>
+                </a:solidFill>
+              </a:rPr>
+              <a:t>Agent-based diagnostic workflow </a:t>
+            </a:r>
+          </a:p>
+          <a:p>
+            <a:pPr marL="342900" lvl="0" indent="-342900">
+              <a:buFont typeface="Arial" panose="020B0604020202020204" pitchFamily="34" charset="0"/>
+              <a:buChar char="•"/>
+            </a:pPr>
+            <a:r>
+              <a:rPr lang="en-IN" dirty="0">
+                <a:solidFill>
+                  <a:schemeClr val="accent1"/>
+                </a:solidFill>
+              </a:rPr>
+              <a:t>Explainable reasoning and fault identification</a:t>
+            </a:r>
+          </a:p>
+          <a:p>
+            <a:pPr lvl="0"/>
+            <a:r>
+              <a:rPr lang="en-IN" dirty="0">
+                <a:solidFill>
+                  <a:schemeClr val="accent1"/>
+                </a:solidFill>
+              </a:rPr>
+              <a:t> </a:t>
+            </a:r>
+          </a:p>
+          <a:p>
+            <a:pPr>
+              <a:buNone/>
+            </a:pPr>
+            <a:r>
+              <a:rPr lang="en-IN" b="1" dirty="0">
+                <a:solidFill>
+                  <a:schemeClr val="accent1"/>
+                </a:solidFill>
+              </a:rPr>
+              <a:t>6. Results &amp; Validation</a:t>
+            </a:r>
+            <a:endParaRPr lang="en-IN" dirty="0">
+              <a:solidFill>
+                <a:schemeClr val="accent1"/>
+              </a:solidFill>
+            </a:endParaRPr>
+          </a:p>
+          <a:p>
+            <a:pPr marL="342900" lvl="0" indent="-342900">
+              <a:buFont typeface="Arial" panose="020B0604020202020204" pitchFamily="34" charset="0"/>
+              <a:buChar char="•"/>
+            </a:pPr>
+            <a:r>
+              <a:rPr lang="en-IN" dirty="0">
+                <a:solidFill>
+                  <a:schemeClr val="accent1"/>
+                </a:solidFill>
+              </a:rPr>
+              <a:t>Bearing fault classification </a:t>
+            </a:r>
+          </a:p>
+          <a:p>
+            <a:pPr marL="342900" lvl="0" indent="-342900">
+              <a:buFont typeface="Arial" panose="020B0604020202020204" pitchFamily="34" charset="0"/>
+              <a:buChar char="•"/>
+            </a:pPr>
+            <a:r>
+              <a:rPr lang="en-IN" dirty="0">
+                <a:solidFill>
+                  <a:schemeClr val="accent1"/>
+                </a:solidFill>
+              </a:rPr>
+              <a:t>Diagnostic explanation </a:t>
+            </a:r>
+          </a:p>
+          <a:p>
+            <a:pPr marL="342900" lvl="0" indent="-342900">
+              <a:buFont typeface="Arial" panose="020B0604020202020204" pitchFamily="34" charset="0"/>
+              <a:buChar char="•"/>
+            </a:pPr>
+            <a:r>
+              <a:rPr lang="en-IN" dirty="0">
+                <a:solidFill>
+                  <a:schemeClr val="accent1"/>
+                </a:solidFill>
+              </a:rPr>
+              <a:t>Accuracy and consistency evaluation</a:t>
+            </a:r>
+          </a:p>
+        </p:txBody>
+      </p:sp>
+      <p:pic>
+        <p:nvPicPr>
+          <p:cNvPr id="14" name="Picture 13">
+            <a:extLst>
+              <a:ext uri="{FF2B5EF4-FFF2-40B4-BE49-F238E27FC236}">
+                <a16:creationId xmlns:a16="http://schemas.microsoft.com/office/drawing/2014/main" id="{706454FF-9B5F-5325-55EB-6DC7C5C5E991}"/>
+              </a:ext>
+            </a:extLst>
+          </p:cNvPr>
+          <p:cNvPicPr>
+            <a:picLocks noChangeAspect="1"/>
+          </p:cNvPicPr>
+          <p:nvPr/>
+        </p:nvPicPr>
+        <p:blipFill>
+          <a:blip r:embed="rId2"/>
+          <a:stretch>
+            <a:fillRect/>
+          </a:stretch>
+        </p:blipFill>
+        <p:spPr>
+          <a:xfrm>
+            <a:off x="1248389" y="1357505"/>
+            <a:ext cx="5476875" cy="4972050"/>
+          </a:xfrm>
+          <a:prstGeom prst="rect">
+            <a:avLst/>
+          </a:prstGeom>
+        </p:spPr>
+      </p:pic>
+    </p:spTree>
+    <p:extLst>
+      <p:ext uri="{BB962C8B-B14F-4D97-AF65-F5344CB8AC3E}">
+        <p14:creationId xmlns:p14="http://schemas.microsoft.com/office/powerpoint/2010/main" val="1187364388"/>
       </p:ext>
     </p:extLst>
   </p:cSld>

</xml_diff>